<commit_message>
updated lab 5 and theory 6
</commit_message>
<xml_diff>
--- a/lab_05-understanding_ui/lab_05-understanding_ui.pptx
+++ b/lab_05-understanding_ui/lab_05-understanding_ui.pptx
@@ -250,7 +250,7 @@
           <a:p>
             <a:fld id="{81C4B3FE-0320-8142-8396-5C3025C019EC}" type="datetimeFigureOut">
               <a:rPr lang="en-IT" smtClean="0"/>
-              <a:t>2/6/24</a:t>
+              <a:t>3/31/25</a:t>
             </a:fld>
             <a:endParaRPr lang="en-IT"/>
           </a:p>
@@ -4324,7 +4324,9 @@
           <a:lstStyle>
             <a:lvl1pPr marL="0" indent="0" algn="ctr">
               <a:buNone/>
-              <a:defRPr sz="4800" b="1"/>
+              <a:defRPr sz="4800" b="1">
+                <a:latin typeface="Aptos" panose="020B0004020202020204" pitchFamily="34" charset="0"/>
+              </a:defRPr>
             </a:lvl1pPr>
             <a:lvl2pPr marL="457200" indent="0" algn="ctr">
               <a:buNone/>
@@ -4410,7 +4412,9 @@
           <a:lstStyle/>
           <a:p>
             <a:pPr algn="ctr"/>
-            <a:endParaRPr lang="en-GB" dirty="0"/>
+            <a:endParaRPr lang="en-GB" dirty="0">
+              <a:latin typeface="Aptos" panose="020B0004020202020204" pitchFamily="34" charset="0"/>
+            </a:endParaRPr>
           </a:p>
         </p:txBody>
       </p:sp>
@@ -4460,7 +4464,9 @@
           <a:lstStyle/>
           <a:p>
             <a:pPr algn="ctr"/>
-            <a:endParaRPr lang="en-GB" dirty="0"/>
+            <a:endParaRPr lang="en-GB" dirty="0">
+              <a:latin typeface="Aptos" panose="020B0004020202020204" pitchFamily="34" charset="0"/>
+            </a:endParaRPr>
           </a:p>
         </p:txBody>
       </p:sp>
@@ -4506,36 +4512,52 @@
           </a:lstStyle>
           <a:p>
             <a:r>
-              <a:rPr lang="it-IT" sz="2800" b="0" dirty="0" err="1"/>
+              <a:rPr lang="it-IT" sz="2800" b="0" dirty="0" err="1">
+                <a:latin typeface="Aptos" panose="020B0004020202020204" pitchFamily="34" charset="0"/>
+              </a:rPr>
               <a:t>Biomedical</a:t>
             </a:r>
             <a:r>
-              <a:rPr lang="it-IT" sz="2800" b="0" dirty="0"/>
+              <a:rPr lang="it-IT" sz="2800" b="0" dirty="0">
+                <a:latin typeface="Aptos" panose="020B0004020202020204" pitchFamily="34" charset="0"/>
+              </a:rPr>
               <a:t> </a:t>
             </a:r>
             <a:r>
-              <a:rPr lang="it-IT" sz="2800" b="0" dirty="0" err="1"/>
+              <a:rPr lang="it-IT" sz="2800" b="0" dirty="0" err="1">
+                <a:latin typeface="Aptos" panose="020B0004020202020204" pitchFamily="34" charset="0"/>
+              </a:rPr>
               <a:t>Wearable</a:t>
             </a:r>
             <a:r>
-              <a:rPr lang="it-IT" sz="2800" b="0" dirty="0"/>
+              <a:rPr lang="it-IT" sz="2800" b="0" dirty="0">
+                <a:latin typeface="Aptos" panose="020B0004020202020204" pitchFamily="34" charset="0"/>
+              </a:rPr>
               <a:t> Technologies </a:t>
             </a:r>
           </a:p>
           <a:p>
             <a:r>
-              <a:rPr lang="it-IT" sz="2800" b="0" dirty="0"/>
+              <a:rPr lang="it-IT" sz="2800" b="0" dirty="0">
+                <a:latin typeface="Aptos" panose="020B0004020202020204" pitchFamily="34" charset="0"/>
+              </a:rPr>
               <a:t>for Healthcare and </a:t>
             </a:r>
             <a:r>
-              <a:rPr lang="it-IT" sz="2800" b="0" dirty="0" err="1"/>
+              <a:rPr lang="it-IT" sz="2800" b="0" dirty="0" err="1">
+                <a:latin typeface="Aptos" panose="020B0004020202020204" pitchFamily="34" charset="0"/>
+              </a:rPr>
               <a:t>Wellbeing</a:t>
             </a:r>
             <a:r>
-              <a:rPr lang="it-IT" sz="2800" b="0" dirty="0"/>
+              <a:rPr lang="it-IT" sz="2800" b="0" dirty="0">
+                <a:latin typeface="Aptos" panose="020B0004020202020204" pitchFamily="34" charset="0"/>
+              </a:rPr>
               <a:t>  </a:t>
             </a:r>
-            <a:endParaRPr lang="en-GB" sz="2800" b="0" dirty="0"/>
+            <a:endParaRPr lang="en-GB" sz="2800" b="0" dirty="0">
+              <a:latin typeface="Aptos" panose="020B0004020202020204" pitchFamily="34" charset="0"/>
+            </a:endParaRPr>
           </a:p>
         </p:txBody>
       </p:sp>
@@ -4586,8 +4608,10 @@
               </a:spcAft>
             </a:pPr>
             <a:r>
-              <a:rPr lang="it-IT" sz="2800" dirty="0"/>
-              <a:t>A.Y. 2023-2024</a:t>
+              <a:rPr lang="it-IT" sz="2800" dirty="0">
+                <a:latin typeface="Aptos" panose="020B0004020202020204" pitchFamily="34" charset="0"/>
+              </a:rPr>
+              <a:t>A.Y. 2024-2025</a:t>
             </a:r>
           </a:p>
         </p:txBody>
@@ -4626,7 +4650,7 @@
                 <a:effectLst/>
                 <a:uLnTx/>
                 <a:uFillTx/>
-                <a:latin typeface="Palatino Linotype" panose="02040502050505030304" pitchFamily="18" charset="0"/>
+                <a:latin typeface="Aptos" panose="020B0004020202020204" pitchFamily="34" charset="0"/>
                 <a:ea typeface="+mj-ea"/>
                 <a:cs typeface="+mj-cs"/>
               </a:rPr>
@@ -4643,7 +4667,7 @@
                 <a:effectLst/>
                 <a:uLnTx/>
                 <a:uFillTx/>
-                <a:latin typeface="Palatino Linotype" panose="02040502050505030304" pitchFamily="18" charset="0"/>
+                <a:latin typeface="Aptos" panose="020B0004020202020204" pitchFamily="34" charset="0"/>
                 <a:ea typeface="+mj-ea"/>
                 <a:cs typeface="+mj-cs"/>
               </a:rPr>
@@ -4660,7 +4684,7 @@
                 <a:effectLst/>
                 <a:uLnTx/>
                 <a:uFillTx/>
-                <a:latin typeface="Palatino Linotype" panose="02040502050505030304" pitchFamily="18" charset="0"/>
+                <a:latin typeface="Aptos" panose="020B0004020202020204" pitchFamily="34" charset="0"/>
                 <a:ea typeface="+mj-ea"/>
                 <a:cs typeface="+mj-cs"/>
               </a:rPr>
@@ -4676,7 +4700,7 @@
                 <a:effectLst/>
                 <a:uLnTx/>
                 <a:uFillTx/>
-                <a:latin typeface="Palatino Linotype" panose="02040502050505030304" pitchFamily="18" charset="0"/>
+                <a:latin typeface="Aptos" panose="020B0004020202020204" pitchFamily="34" charset="0"/>
                 <a:ea typeface="+mj-ea"/>
                 <a:cs typeface="+mj-cs"/>
               </a:rPr>
@@ -4693,7 +4717,7 @@
                 <a:effectLst/>
                 <a:uLnTx/>
                 <a:uFillTx/>
-                <a:latin typeface="Palatino Linotype" panose="02040502050505030304" pitchFamily="18" charset="0"/>
+                <a:latin typeface="Aptos" panose="020B0004020202020204" pitchFamily="34" charset="0"/>
                 <a:ea typeface="+mj-ea"/>
                 <a:cs typeface="+mj-cs"/>
               </a:rPr>
@@ -4710,13 +4734,15 @@
                 <a:effectLst/>
                 <a:uLnTx/>
                 <a:uFillTx/>
-                <a:latin typeface="Palatino Linotype" panose="02040502050505030304" pitchFamily="18" charset="0"/>
+                <a:latin typeface="Aptos" panose="020B0004020202020204" pitchFamily="34" charset="0"/>
                 <a:ea typeface="+mj-ea"/>
                 <a:cs typeface="+mj-cs"/>
               </a:rPr>
               <a:t>Engineering</a:t>
             </a:r>
-            <a:endParaRPr lang="en-GB" sz="1100" cap="small" baseline="0" dirty="0"/>
+            <a:endParaRPr lang="en-GB" sz="1100" cap="small" baseline="0" dirty="0">
+              <a:latin typeface="Aptos" panose="020B0004020202020204" pitchFamily="34" charset="0"/>
+            </a:endParaRPr>
           </a:p>
         </p:txBody>
       </p:sp>
@@ -4826,7 +4852,9 @@
           </a:bodyPr>
           <a:lstStyle>
             <a:lvl1pPr>
-              <a:defRPr sz="3200"/>
+              <a:defRPr sz="3200">
+                <a:latin typeface="Aptos" panose="020B0004020202020204" pitchFamily="34" charset="0"/>
+              </a:defRPr>
             </a:lvl1pPr>
           </a:lstStyle>
           <a:p>
@@ -5226,12 +5254,14 @@
                     <a:tint val="75000"/>
                   </a:schemeClr>
                 </a:solidFill>
+                <a:latin typeface="Aptos" panose="020B0004020202020204" pitchFamily="34" charset="0"/>
               </a:defRPr>
             </a:lvl1pPr>
           </a:lstStyle>
           <a:p>
             <a:fld id="{31DE2C5B-556E-47B8-A792-024C2FCA4ACC}" type="slidenum">
               <a:rPr lang="en-GB" smtClean="0"/>
+              <a:pPr/>
               <a:t>‹#›</a:t>
             </a:fld>
             <a:endParaRPr lang="en-GB"/>
@@ -5267,7 +5297,7 @@
           <a:solidFill>
             <a:schemeClr val="tx1"/>
           </a:solidFill>
-          <a:latin typeface="Palatino Linotype" panose="02040502050505030304" pitchFamily="18" charset="0"/>
+          <a:latin typeface="Aptos" panose="020B0004020202020204" pitchFamily="34" charset="0"/>
           <a:ea typeface="+mj-ea"/>
           <a:cs typeface="+mj-cs"/>
         </a:defRPr>
@@ -5290,7 +5320,7 @@
           <a:solidFill>
             <a:schemeClr val="tx1"/>
           </a:solidFill>
-          <a:latin typeface="Palatino Linotype" panose="02040502050505030304" pitchFamily="18" charset="0"/>
+          <a:latin typeface="Aptos" panose="020B0004020202020204" pitchFamily="34" charset="0"/>
           <a:ea typeface="+mn-ea"/>
           <a:cs typeface="+mn-cs"/>
         </a:defRPr>
@@ -5311,7 +5341,7 @@
           <a:solidFill>
             <a:schemeClr val="tx1"/>
           </a:solidFill>
-          <a:latin typeface="Palatino Linotype" panose="02040502050505030304" pitchFamily="18" charset="0"/>
+          <a:latin typeface="Aptos" panose="020B0004020202020204" pitchFamily="34" charset="0"/>
           <a:ea typeface="+mn-ea"/>
           <a:cs typeface="+mn-cs"/>
         </a:defRPr>
@@ -5332,7 +5362,7 @@
           <a:solidFill>
             <a:schemeClr val="tx1"/>
           </a:solidFill>
-          <a:latin typeface="Palatino Linotype" panose="02040502050505030304" pitchFamily="18" charset="0"/>
+          <a:latin typeface="Aptos" panose="020B0004020202020204" pitchFamily="34" charset="0"/>
           <a:ea typeface="+mn-ea"/>
           <a:cs typeface="+mn-cs"/>
         </a:defRPr>
@@ -5353,7 +5383,7 @@
           <a:solidFill>
             <a:schemeClr val="tx1"/>
           </a:solidFill>
-          <a:latin typeface="Palatino Linotype" panose="02040502050505030304" pitchFamily="18" charset="0"/>
+          <a:latin typeface="Aptos" panose="020B0004020202020204" pitchFamily="34" charset="0"/>
           <a:ea typeface="+mn-ea"/>
           <a:cs typeface="+mn-cs"/>
         </a:defRPr>
@@ -5374,7 +5404,7 @@
           <a:solidFill>
             <a:schemeClr val="tx1"/>
           </a:solidFill>
-          <a:latin typeface="Palatino Linotype" panose="02040502050505030304" pitchFamily="18" charset="0"/>
+          <a:latin typeface="Aptos" panose="020B0004020202020204" pitchFamily="34" charset="0"/>
           <a:ea typeface="+mn-ea"/>
           <a:cs typeface="+mn-cs"/>
         </a:defRPr>
@@ -6103,7 +6133,9 @@
           </a:lstStyle>
           <a:p>
             <a:r>
-              <a:rPr lang="en-IT" dirty="0"/>
+              <a:rPr lang="en-IT" dirty="0">
+                <a:latin typeface="Aptos" panose="020B0004020202020204" pitchFamily="34" charset="0"/>
+              </a:rPr>
               <a:t>Of course, there are many others…</a:t>
             </a:r>
           </a:p>
@@ -6444,220 +6476,6 @@
           </a:p>
         </p:txBody>
       </p:sp>
-      <p:sp>
-        <p:nvSpPr>
-          <p:cNvPr id="9" name="Content Placeholder 2">
-            <a:extLst>
-              <a:ext uri="{FF2B5EF4-FFF2-40B4-BE49-F238E27FC236}">
-                <a16:creationId xmlns:a16="http://schemas.microsoft.com/office/drawing/2014/main" id="{AC4F1A50-E1EA-F24E-B18E-60494901689B}"/>
-              </a:ext>
-            </a:extLst>
-          </p:cNvPr>
-          <p:cNvSpPr txBox="1">
-            <a:spLocks/>
-          </p:cNvSpPr>
-          <p:nvPr/>
-        </p:nvSpPr>
-        <p:spPr>
-          <a:xfrm>
-            <a:off x="284171" y="6270339"/>
-            <a:ext cx="10969429" cy="650277"/>
-          </a:xfrm>
-          <a:prstGeom prst="rect">
-            <a:avLst/>
-          </a:prstGeom>
-        </p:spPr>
-        <p:txBody>
-          <a:bodyPr vert="horz" lIns="91440" tIns="45720" rIns="91440" bIns="45720" rtlCol="0">
-            <a:normAutofit/>
-          </a:bodyPr>
-          <a:lstStyle>
-            <a:lvl1pPr marL="342900" indent="-342900" algn="l" defTabSz="914400" rtl="0" eaLnBrk="1" latinLnBrk="0" hangingPunct="1">
-              <a:lnSpc>
-                <a:spcPct val="90000"/>
-              </a:lnSpc>
-              <a:spcBef>
-                <a:spcPts val="1000"/>
-              </a:spcBef>
-              <a:buClr>
-                <a:srgbClr val="00B050"/>
-              </a:buClr>
-              <a:buFont typeface="Wingdings" panose="05000000000000000000" pitchFamily="2" charset="2"/>
-              <a:buChar char="Ø"/>
-              <a:defRPr sz="2400" kern="1200">
-                <a:solidFill>
-                  <a:schemeClr val="tx1"/>
-                </a:solidFill>
-                <a:latin typeface="Palatino Linotype" panose="02040502050505030304" pitchFamily="18" charset="0"/>
-                <a:ea typeface="+mn-ea"/>
-                <a:cs typeface="+mn-cs"/>
-              </a:defRPr>
-            </a:lvl1pPr>
-            <a:lvl2pPr marL="685800" indent="-228600" algn="l" defTabSz="914400" rtl="0" eaLnBrk="1" latinLnBrk="0" hangingPunct="1">
-              <a:lnSpc>
-                <a:spcPct val="90000"/>
-              </a:lnSpc>
-              <a:spcBef>
-                <a:spcPts val="500"/>
-              </a:spcBef>
-              <a:buClr>
-                <a:srgbClr val="00B050"/>
-              </a:buClr>
-              <a:buFont typeface="Wingdings" panose="05000000000000000000" pitchFamily="2" charset="2"/>
-              <a:buChar char="§"/>
-              <a:defRPr sz="2000" kern="1200">
-                <a:solidFill>
-                  <a:schemeClr val="tx1"/>
-                </a:solidFill>
-                <a:latin typeface="Palatino Linotype" panose="02040502050505030304" pitchFamily="18" charset="0"/>
-                <a:ea typeface="+mn-ea"/>
-                <a:cs typeface="+mn-cs"/>
-              </a:defRPr>
-            </a:lvl2pPr>
-            <a:lvl3pPr marL="1143000" indent="-228600" algn="l" defTabSz="914400" rtl="0" eaLnBrk="1" latinLnBrk="0" hangingPunct="1">
-              <a:lnSpc>
-                <a:spcPct val="90000"/>
-              </a:lnSpc>
-              <a:spcBef>
-                <a:spcPts val="500"/>
-              </a:spcBef>
-              <a:buClr>
-                <a:srgbClr val="00B050"/>
-              </a:buClr>
-              <a:buFont typeface="Arial" panose="020B0604020202020204" pitchFamily="34" charset="0"/>
-              <a:buChar char="•"/>
-              <a:defRPr sz="1800" kern="1200">
-                <a:solidFill>
-                  <a:schemeClr val="tx1"/>
-                </a:solidFill>
-                <a:latin typeface="Palatino Linotype" panose="02040502050505030304" pitchFamily="18" charset="0"/>
-                <a:ea typeface="+mn-ea"/>
-                <a:cs typeface="+mn-cs"/>
-              </a:defRPr>
-            </a:lvl3pPr>
-            <a:lvl4pPr marL="1600200" indent="-228600" algn="l" defTabSz="914400" rtl="0" eaLnBrk="1" latinLnBrk="0" hangingPunct="1">
-              <a:lnSpc>
-                <a:spcPct val="90000"/>
-              </a:lnSpc>
-              <a:spcBef>
-                <a:spcPts val="500"/>
-              </a:spcBef>
-              <a:buClr>
-                <a:srgbClr val="00B050"/>
-              </a:buClr>
-              <a:buFont typeface="Courier New" panose="02070309020205020404" pitchFamily="49" charset="0"/>
-              <a:buChar char="o"/>
-              <a:defRPr sz="1600" kern="1200">
-                <a:solidFill>
-                  <a:schemeClr val="tx1"/>
-                </a:solidFill>
-                <a:latin typeface="Palatino Linotype" panose="02040502050505030304" pitchFamily="18" charset="0"/>
-                <a:ea typeface="+mn-ea"/>
-                <a:cs typeface="+mn-cs"/>
-              </a:defRPr>
-            </a:lvl4pPr>
-            <a:lvl5pPr marL="2057400" indent="-228600" algn="l" defTabSz="914400" rtl="0" eaLnBrk="1" latinLnBrk="0" hangingPunct="1">
-              <a:lnSpc>
-                <a:spcPct val="90000"/>
-              </a:lnSpc>
-              <a:spcBef>
-                <a:spcPts val="500"/>
-              </a:spcBef>
-              <a:buClr>
-                <a:srgbClr val="00B050"/>
-              </a:buClr>
-              <a:buFont typeface="Times New Roman" panose="02020603050405020304" pitchFamily="18" charset="0"/>
-              <a:buChar char="̶"/>
-              <a:defRPr sz="1600" kern="1200">
-                <a:solidFill>
-                  <a:schemeClr val="tx1"/>
-                </a:solidFill>
-                <a:latin typeface="Palatino Linotype" panose="02040502050505030304" pitchFamily="18" charset="0"/>
-                <a:ea typeface="+mn-ea"/>
-                <a:cs typeface="+mn-cs"/>
-              </a:defRPr>
-            </a:lvl5pPr>
-            <a:lvl6pPr marL="2514600" indent="-228600" algn="l" defTabSz="914400" rtl="0" eaLnBrk="1" latinLnBrk="0" hangingPunct="1">
-              <a:lnSpc>
-                <a:spcPct val="90000"/>
-              </a:lnSpc>
-              <a:spcBef>
-                <a:spcPts val="500"/>
-              </a:spcBef>
-              <a:buFont typeface="Arial" panose="020B0604020202020204" pitchFamily="34" charset="0"/>
-              <a:buChar char="•"/>
-              <a:defRPr sz="1800" kern="1200">
-                <a:solidFill>
-                  <a:schemeClr val="tx1"/>
-                </a:solidFill>
-                <a:latin typeface="+mn-lt"/>
-                <a:ea typeface="+mn-ea"/>
-                <a:cs typeface="+mn-cs"/>
-              </a:defRPr>
-            </a:lvl6pPr>
-            <a:lvl7pPr marL="2971800" indent="-228600" algn="l" defTabSz="914400" rtl="0" eaLnBrk="1" latinLnBrk="0" hangingPunct="1">
-              <a:lnSpc>
-                <a:spcPct val="90000"/>
-              </a:lnSpc>
-              <a:spcBef>
-                <a:spcPts val="500"/>
-              </a:spcBef>
-              <a:buFont typeface="Arial" panose="020B0604020202020204" pitchFamily="34" charset="0"/>
-              <a:buChar char="•"/>
-              <a:defRPr sz="1800" kern="1200">
-                <a:solidFill>
-                  <a:schemeClr val="tx1"/>
-                </a:solidFill>
-                <a:latin typeface="+mn-lt"/>
-                <a:ea typeface="+mn-ea"/>
-                <a:cs typeface="+mn-cs"/>
-              </a:defRPr>
-            </a:lvl7pPr>
-            <a:lvl8pPr marL="3429000" indent="-228600" algn="l" defTabSz="914400" rtl="0" eaLnBrk="1" latinLnBrk="0" hangingPunct="1">
-              <a:lnSpc>
-                <a:spcPct val="90000"/>
-              </a:lnSpc>
-              <a:spcBef>
-                <a:spcPts val="500"/>
-              </a:spcBef>
-              <a:buFont typeface="Arial" panose="020B0604020202020204" pitchFamily="34" charset="0"/>
-              <a:buChar char="•"/>
-              <a:defRPr sz="1800" kern="1200">
-                <a:solidFill>
-                  <a:schemeClr val="tx1"/>
-                </a:solidFill>
-                <a:latin typeface="+mn-lt"/>
-                <a:ea typeface="+mn-ea"/>
-                <a:cs typeface="+mn-cs"/>
-              </a:defRPr>
-            </a:lvl8pPr>
-            <a:lvl9pPr marL="3886200" indent="-228600" algn="l" defTabSz="914400" rtl="0" eaLnBrk="1" latinLnBrk="0" hangingPunct="1">
-              <a:lnSpc>
-                <a:spcPct val="90000"/>
-              </a:lnSpc>
-              <a:spcBef>
-                <a:spcPts val="500"/>
-              </a:spcBef>
-              <a:buFont typeface="Arial" panose="020B0604020202020204" pitchFamily="34" charset="0"/>
-              <a:buChar char="•"/>
-              <a:defRPr sz="1800" kern="1200">
-                <a:solidFill>
-                  <a:schemeClr val="tx1"/>
-                </a:solidFill>
-                <a:latin typeface="+mn-lt"/>
-                <a:ea typeface="+mn-ea"/>
-                <a:cs typeface="+mn-cs"/>
-              </a:defRPr>
-            </a:lvl9pPr>
-          </a:lstStyle>
-          <a:p>
-            <a:r>
-              <a:rPr lang="en-IT" dirty="0"/>
-              <a:t>Of course, there are many others…</a:t>
-            </a:r>
-          </a:p>
-        </p:txBody>
-      </p:sp>
       <p:pic>
         <p:nvPicPr>
           <p:cNvPr id="6" name="Picture 5" descr="Graphical user interface, application, Word&#10;&#10;Description automatically generated">
@@ -6756,6 +6574,222 @@
               <a:t>11</a:t>
             </a:fld>
             <a:endParaRPr lang="en-GB"/>
+          </a:p>
+        </p:txBody>
+      </p:sp>
+      <p:sp>
+        <p:nvSpPr>
+          <p:cNvPr id="5" name="Content Placeholder 2">
+            <a:extLst>
+              <a:ext uri="{FF2B5EF4-FFF2-40B4-BE49-F238E27FC236}">
+                <a16:creationId xmlns:a16="http://schemas.microsoft.com/office/drawing/2014/main" id="{183E01F5-880A-5DD4-503D-A6711F2085F7}"/>
+              </a:ext>
+            </a:extLst>
+          </p:cNvPr>
+          <p:cNvSpPr txBox="1">
+            <a:spLocks/>
+          </p:cNvSpPr>
+          <p:nvPr/>
+        </p:nvSpPr>
+        <p:spPr>
+          <a:xfrm>
+            <a:off x="284171" y="6270339"/>
+            <a:ext cx="10969429" cy="650277"/>
+          </a:xfrm>
+          <a:prstGeom prst="rect">
+            <a:avLst/>
+          </a:prstGeom>
+        </p:spPr>
+        <p:txBody>
+          <a:bodyPr vert="horz" lIns="91440" tIns="45720" rIns="91440" bIns="45720" rtlCol="0">
+            <a:normAutofit/>
+          </a:bodyPr>
+          <a:lstStyle>
+            <a:lvl1pPr marL="342900" indent="-342900" algn="l" defTabSz="914400" rtl="0" eaLnBrk="1" latinLnBrk="0" hangingPunct="1">
+              <a:lnSpc>
+                <a:spcPct val="90000"/>
+              </a:lnSpc>
+              <a:spcBef>
+                <a:spcPts val="1000"/>
+              </a:spcBef>
+              <a:buClr>
+                <a:srgbClr val="00B050"/>
+              </a:buClr>
+              <a:buFont typeface="Wingdings" panose="05000000000000000000" pitchFamily="2" charset="2"/>
+              <a:buChar char="Ø"/>
+              <a:defRPr sz="2400" kern="1200">
+                <a:solidFill>
+                  <a:schemeClr val="tx1"/>
+                </a:solidFill>
+                <a:latin typeface="Palatino Linotype" panose="02040502050505030304" pitchFamily="18" charset="0"/>
+                <a:ea typeface="+mn-ea"/>
+                <a:cs typeface="+mn-cs"/>
+              </a:defRPr>
+            </a:lvl1pPr>
+            <a:lvl2pPr marL="685800" indent="-228600" algn="l" defTabSz="914400" rtl="0" eaLnBrk="1" latinLnBrk="0" hangingPunct="1">
+              <a:lnSpc>
+                <a:spcPct val="90000"/>
+              </a:lnSpc>
+              <a:spcBef>
+                <a:spcPts val="500"/>
+              </a:spcBef>
+              <a:buClr>
+                <a:srgbClr val="00B050"/>
+              </a:buClr>
+              <a:buFont typeface="Wingdings" panose="05000000000000000000" pitchFamily="2" charset="2"/>
+              <a:buChar char="§"/>
+              <a:defRPr sz="2000" kern="1200">
+                <a:solidFill>
+                  <a:schemeClr val="tx1"/>
+                </a:solidFill>
+                <a:latin typeface="Palatino Linotype" panose="02040502050505030304" pitchFamily="18" charset="0"/>
+                <a:ea typeface="+mn-ea"/>
+                <a:cs typeface="+mn-cs"/>
+              </a:defRPr>
+            </a:lvl2pPr>
+            <a:lvl3pPr marL="1143000" indent="-228600" algn="l" defTabSz="914400" rtl="0" eaLnBrk="1" latinLnBrk="0" hangingPunct="1">
+              <a:lnSpc>
+                <a:spcPct val="90000"/>
+              </a:lnSpc>
+              <a:spcBef>
+                <a:spcPts val="500"/>
+              </a:spcBef>
+              <a:buClr>
+                <a:srgbClr val="00B050"/>
+              </a:buClr>
+              <a:buFont typeface="Arial" panose="020B0604020202020204" pitchFamily="34" charset="0"/>
+              <a:buChar char="•"/>
+              <a:defRPr sz="1800" kern="1200">
+                <a:solidFill>
+                  <a:schemeClr val="tx1"/>
+                </a:solidFill>
+                <a:latin typeface="Palatino Linotype" panose="02040502050505030304" pitchFamily="18" charset="0"/>
+                <a:ea typeface="+mn-ea"/>
+                <a:cs typeface="+mn-cs"/>
+              </a:defRPr>
+            </a:lvl3pPr>
+            <a:lvl4pPr marL="1600200" indent="-228600" algn="l" defTabSz="914400" rtl="0" eaLnBrk="1" latinLnBrk="0" hangingPunct="1">
+              <a:lnSpc>
+                <a:spcPct val="90000"/>
+              </a:lnSpc>
+              <a:spcBef>
+                <a:spcPts val="500"/>
+              </a:spcBef>
+              <a:buClr>
+                <a:srgbClr val="00B050"/>
+              </a:buClr>
+              <a:buFont typeface="Courier New" panose="02070309020205020404" pitchFamily="49" charset="0"/>
+              <a:buChar char="o"/>
+              <a:defRPr sz="1600" kern="1200">
+                <a:solidFill>
+                  <a:schemeClr val="tx1"/>
+                </a:solidFill>
+                <a:latin typeface="Palatino Linotype" panose="02040502050505030304" pitchFamily="18" charset="0"/>
+                <a:ea typeface="+mn-ea"/>
+                <a:cs typeface="+mn-cs"/>
+              </a:defRPr>
+            </a:lvl4pPr>
+            <a:lvl5pPr marL="2057400" indent="-228600" algn="l" defTabSz="914400" rtl="0" eaLnBrk="1" latinLnBrk="0" hangingPunct="1">
+              <a:lnSpc>
+                <a:spcPct val="90000"/>
+              </a:lnSpc>
+              <a:spcBef>
+                <a:spcPts val="500"/>
+              </a:spcBef>
+              <a:buClr>
+                <a:srgbClr val="00B050"/>
+              </a:buClr>
+              <a:buFont typeface="Times New Roman" panose="02020603050405020304" pitchFamily="18" charset="0"/>
+              <a:buChar char="̶"/>
+              <a:defRPr sz="1600" kern="1200">
+                <a:solidFill>
+                  <a:schemeClr val="tx1"/>
+                </a:solidFill>
+                <a:latin typeface="Palatino Linotype" panose="02040502050505030304" pitchFamily="18" charset="0"/>
+                <a:ea typeface="+mn-ea"/>
+                <a:cs typeface="+mn-cs"/>
+              </a:defRPr>
+            </a:lvl5pPr>
+            <a:lvl6pPr marL="2514600" indent="-228600" algn="l" defTabSz="914400" rtl="0" eaLnBrk="1" latinLnBrk="0" hangingPunct="1">
+              <a:lnSpc>
+                <a:spcPct val="90000"/>
+              </a:lnSpc>
+              <a:spcBef>
+                <a:spcPts val="500"/>
+              </a:spcBef>
+              <a:buFont typeface="Arial" panose="020B0604020202020204" pitchFamily="34" charset="0"/>
+              <a:buChar char="•"/>
+              <a:defRPr sz="1800" kern="1200">
+                <a:solidFill>
+                  <a:schemeClr val="tx1"/>
+                </a:solidFill>
+                <a:latin typeface="+mn-lt"/>
+                <a:ea typeface="+mn-ea"/>
+                <a:cs typeface="+mn-cs"/>
+              </a:defRPr>
+            </a:lvl6pPr>
+            <a:lvl7pPr marL="2971800" indent="-228600" algn="l" defTabSz="914400" rtl="0" eaLnBrk="1" latinLnBrk="0" hangingPunct="1">
+              <a:lnSpc>
+                <a:spcPct val="90000"/>
+              </a:lnSpc>
+              <a:spcBef>
+                <a:spcPts val="500"/>
+              </a:spcBef>
+              <a:buFont typeface="Arial" panose="020B0604020202020204" pitchFamily="34" charset="0"/>
+              <a:buChar char="•"/>
+              <a:defRPr sz="1800" kern="1200">
+                <a:solidFill>
+                  <a:schemeClr val="tx1"/>
+                </a:solidFill>
+                <a:latin typeface="+mn-lt"/>
+                <a:ea typeface="+mn-ea"/>
+                <a:cs typeface="+mn-cs"/>
+              </a:defRPr>
+            </a:lvl7pPr>
+            <a:lvl8pPr marL="3429000" indent="-228600" algn="l" defTabSz="914400" rtl="0" eaLnBrk="1" latinLnBrk="0" hangingPunct="1">
+              <a:lnSpc>
+                <a:spcPct val="90000"/>
+              </a:lnSpc>
+              <a:spcBef>
+                <a:spcPts val="500"/>
+              </a:spcBef>
+              <a:buFont typeface="Arial" panose="020B0604020202020204" pitchFamily="34" charset="0"/>
+              <a:buChar char="•"/>
+              <a:defRPr sz="1800" kern="1200">
+                <a:solidFill>
+                  <a:schemeClr val="tx1"/>
+                </a:solidFill>
+                <a:latin typeface="+mn-lt"/>
+                <a:ea typeface="+mn-ea"/>
+                <a:cs typeface="+mn-cs"/>
+              </a:defRPr>
+            </a:lvl8pPr>
+            <a:lvl9pPr marL="3886200" indent="-228600" algn="l" defTabSz="914400" rtl="0" eaLnBrk="1" latinLnBrk="0" hangingPunct="1">
+              <a:lnSpc>
+                <a:spcPct val="90000"/>
+              </a:lnSpc>
+              <a:spcBef>
+                <a:spcPts val="500"/>
+              </a:spcBef>
+              <a:buFont typeface="Arial" panose="020B0604020202020204" pitchFamily="34" charset="0"/>
+              <a:buChar char="•"/>
+              <a:defRPr sz="1800" kern="1200">
+                <a:solidFill>
+                  <a:schemeClr val="tx1"/>
+                </a:solidFill>
+                <a:latin typeface="+mn-lt"/>
+                <a:ea typeface="+mn-ea"/>
+                <a:cs typeface="+mn-cs"/>
+              </a:defRPr>
+            </a:lvl9pPr>
+          </a:lstStyle>
+          <a:p>
+            <a:r>
+              <a:rPr lang="en-IT" dirty="0">
+                <a:latin typeface="Aptos" panose="020B0004020202020204" pitchFamily="34" charset="0"/>
+              </a:rPr>
+              <a:t>Of course, there are many others…</a:t>
+            </a:r>
           </a:p>
         </p:txBody>
       </p:sp>
@@ -7029,220 +7063,6 @@
           </a:p>
         </p:txBody>
       </p:sp>
-      <p:sp>
-        <p:nvSpPr>
-          <p:cNvPr id="9" name="Content Placeholder 2">
-            <a:extLst>
-              <a:ext uri="{FF2B5EF4-FFF2-40B4-BE49-F238E27FC236}">
-                <a16:creationId xmlns:a16="http://schemas.microsoft.com/office/drawing/2014/main" id="{AC4F1A50-E1EA-F24E-B18E-60494901689B}"/>
-              </a:ext>
-            </a:extLst>
-          </p:cNvPr>
-          <p:cNvSpPr txBox="1">
-            <a:spLocks/>
-          </p:cNvSpPr>
-          <p:nvPr/>
-        </p:nvSpPr>
-        <p:spPr>
-          <a:xfrm>
-            <a:off x="284171" y="6270339"/>
-            <a:ext cx="10969429" cy="650277"/>
-          </a:xfrm>
-          <a:prstGeom prst="rect">
-            <a:avLst/>
-          </a:prstGeom>
-        </p:spPr>
-        <p:txBody>
-          <a:bodyPr vert="horz" lIns="91440" tIns="45720" rIns="91440" bIns="45720" rtlCol="0">
-            <a:normAutofit/>
-          </a:bodyPr>
-          <a:lstStyle>
-            <a:lvl1pPr marL="342900" indent="-342900" algn="l" defTabSz="914400" rtl="0" eaLnBrk="1" latinLnBrk="0" hangingPunct="1">
-              <a:lnSpc>
-                <a:spcPct val="90000"/>
-              </a:lnSpc>
-              <a:spcBef>
-                <a:spcPts val="1000"/>
-              </a:spcBef>
-              <a:buClr>
-                <a:srgbClr val="00B050"/>
-              </a:buClr>
-              <a:buFont typeface="Wingdings" panose="05000000000000000000" pitchFamily="2" charset="2"/>
-              <a:buChar char="Ø"/>
-              <a:defRPr sz="2400" kern="1200">
-                <a:solidFill>
-                  <a:schemeClr val="tx1"/>
-                </a:solidFill>
-                <a:latin typeface="Palatino Linotype" panose="02040502050505030304" pitchFamily="18" charset="0"/>
-                <a:ea typeface="+mn-ea"/>
-                <a:cs typeface="+mn-cs"/>
-              </a:defRPr>
-            </a:lvl1pPr>
-            <a:lvl2pPr marL="685800" indent="-228600" algn="l" defTabSz="914400" rtl="0" eaLnBrk="1" latinLnBrk="0" hangingPunct="1">
-              <a:lnSpc>
-                <a:spcPct val="90000"/>
-              </a:lnSpc>
-              <a:spcBef>
-                <a:spcPts val="500"/>
-              </a:spcBef>
-              <a:buClr>
-                <a:srgbClr val="00B050"/>
-              </a:buClr>
-              <a:buFont typeface="Wingdings" panose="05000000000000000000" pitchFamily="2" charset="2"/>
-              <a:buChar char="§"/>
-              <a:defRPr sz="2000" kern="1200">
-                <a:solidFill>
-                  <a:schemeClr val="tx1"/>
-                </a:solidFill>
-                <a:latin typeface="Palatino Linotype" panose="02040502050505030304" pitchFamily="18" charset="0"/>
-                <a:ea typeface="+mn-ea"/>
-                <a:cs typeface="+mn-cs"/>
-              </a:defRPr>
-            </a:lvl2pPr>
-            <a:lvl3pPr marL="1143000" indent="-228600" algn="l" defTabSz="914400" rtl="0" eaLnBrk="1" latinLnBrk="0" hangingPunct="1">
-              <a:lnSpc>
-                <a:spcPct val="90000"/>
-              </a:lnSpc>
-              <a:spcBef>
-                <a:spcPts val="500"/>
-              </a:spcBef>
-              <a:buClr>
-                <a:srgbClr val="00B050"/>
-              </a:buClr>
-              <a:buFont typeface="Arial" panose="020B0604020202020204" pitchFamily="34" charset="0"/>
-              <a:buChar char="•"/>
-              <a:defRPr sz="1800" kern="1200">
-                <a:solidFill>
-                  <a:schemeClr val="tx1"/>
-                </a:solidFill>
-                <a:latin typeface="Palatino Linotype" panose="02040502050505030304" pitchFamily="18" charset="0"/>
-                <a:ea typeface="+mn-ea"/>
-                <a:cs typeface="+mn-cs"/>
-              </a:defRPr>
-            </a:lvl3pPr>
-            <a:lvl4pPr marL="1600200" indent="-228600" algn="l" defTabSz="914400" rtl="0" eaLnBrk="1" latinLnBrk="0" hangingPunct="1">
-              <a:lnSpc>
-                <a:spcPct val="90000"/>
-              </a:lnSpc>
-              <a:spcBef>
-                <a:spcPts val="500"/>
-              </a:spcBef>
-              <a:buClr>
-                <a:srgbClr val="00B050"/>
-              </a:buClr>
-              <a:buFont typeface="Courier New" panose="02070309020205020404" pitchFamily="49" charset="0"/>
-              <a:buChar char="o"/>
-              <a:defRPr sz="1600" kern="1200">
-                <a:solidFill>
-                  <a:schemeClr val="tx1"/>
-                </a:solidFill>
-                <a:latin typeface="Palatino Linotype" panose="02040502050505030304" pitchFamily="18" charset="0"/>
-                <a:ea typeface="+mn-ea"/>
-                <a:cs typeface="+mn-cs"/>
-              </a:defRPr>
-            </a:lvl4pPr>
-            <a:lvl5pPr marL="2057400" indent="-228600" algn="l" defTabSz="914400" rtl="0" eaLnBrk="1" latinLnBrk="0" hangingPunct="1">
-              <a:lnSpc>
-                <a:spcPct val="90000"/>
-              </a:lnSpc>
-              <a:spcBef>
-                <a:spcPts val="500"/>
-              </a:spcBef>
-              <a:buClr>
-                <a:srgbClr val="00B050"/>
-              </a:buClr>
-              <a:buFont typeface="Times New Roman" panose="02020603050405020304" pitchFamily="18" charset="0"/>
-              <a:buChar char="̶"/>
-              <a:defRPr sz="1600" kern="1200">
-                <a:solidFill>
-                  <a:schemeClr val="tx1"/>
-                </a:solidFill>
-                <a:latin typeface="Palatino Linotype" panose="02040502050505030304" pitchFamily="18" charset="0"/>
-                <a:ea typeface="+mn-ea"/>
-                <a:cs typeface="+mn-cs"/>
-              </a:defRPr>
-            </a:lvl5pPr>
-            <a:lvl6pPr marL="2514600" indent="-228600" algn="l" defTabSz="914400" rtl="0" eaLnBrk="1" latinLnBrk="0" hangingPunct="1">
-              <a:lnSpc>
-                <a:spcPct val="90000"/>
-              </a:lnSpc>
-              <a:spcBef>
-                <a:spcPts val="500"/>
-              </a:spcBef>
-              <a:buFont typeface="Arial" panose="020B0604020202020204" pitchFamily="34" charset="0"/>
-              <a:buChar char="•"/>
-              <a:defRPr sz="1800" kern="1200">
-                <a:solidFill>
-                  <a:schemeClr val="tx1"/>
-                </a:solidFill>
-                <a:latin typeface="+mn-lt"/>
-                <a:ea typeface="+mn-ea"/>
-                <a:cs typeface="+mn-cs"/>
-              </a:defRPr>
-            </a:lvl6pPr>
-            <a:lvl7pPr marL="2971800" indent="-228600" algn="l" defTabSz="914400" rtl="0" eaLnBrk="1" latinLnBrk="0" hangingPunct="1">
-              <a:lnSpc>
-                <a:spcPct val="90000"/>
-              </a:lnSpc>
-              <a:spcBef>
-                <a:spcPts val="500"/>
-              </a:spcBef>
-              <a:buFont typeface="Arial" panose="020B0604020202020204" pitchFamily="34" charset="0"/>
-              <a:buChar char="•"/>
-              <a:defRPr sz="1800" kern="1200">
-                <a:solidFill>
-                  <a:schemeClr val="tx1"/>
-                </a:solidFill>
-                <a:latin typeface="+mn-lt"/>
-                <a:ea typeface="+mn-ea"/>
-                <a:cs typeface="+mn-cs"/>
-              </a:defRPr>
-            </a:lvl7pPr>
-            <a:lvl8pPr marL="3429000" indent="-228600" algn="l" defTabSz="914400" rtl="0" eaLnBrk="1" latinLnBrk="0" hangingPunct="1">
-              <a:lnSpc>
-                <a:spcPct val="90000"/>
-              </a:lnSpc>
-              <a:spcBef>
-                <a:spcPts val="500"/>
-              </a:spcBef>
-              <a:buFont typeface="Arial" panose="020B0604020202020204" pitchFamily="34" charset="0"/>
-              <a:buChar char="•"/>
-              <a:defRPr sz="1800" kern="1200">
-                <a:solidFill>
-                  <a:schemeClr val="tx1"/>
-                </a:solidFill>
-                <a:latin typeface="+mn-lt"/>
-                <a:ea typeface="+mn-ea"/>
-                <a:cs typeface="+mn-cs"/>
-              </a:defRPr>
-            </a:lvl8pPr>
-            <a:lvl9pPr marL="3886200" indent="-228600" algn="l" defTabSz="914400" rtl="0" eaLnBrk="1" latinLnBrk="0" hangingPunct="1">
-              <a:lnSpc>
-                <a:spcPct val="90000"/>
-              </a:lnSpc>
-              <a:spcBef>
-                <a:spcPts val="500"/>
-              </a:spcBef>
-              <a:buFont typeface="Arial" panose="020B0604020202020204" pitchFamily="34" charset="0"/>
-              <a:buChar char="•"/>
-              <a:defRPr sz="1800" kern="1200">
-                <a:solidFill>
-                  <a:schemeClr val="tx1"/>
-                </a:solidFill>
-                <a:latin typeface="+mn-lt"/>
-                <a:ea typeface="+mn-ea"/>
-                <a:cs typeface="+mn-cs"/>
-              </a:defRPr>
-            </a:lvl9pPr>
-          </a:lstStyle>
-          <a:p>
-            <a:r>
-              <a:rPr lang="en-IT" dirty="0"/>
-              <a:t>Of course, there are many others…</a:t>
-            </a:r>
-          </a:p>
-        </p:txBody>
-      </p:sp>
       <p:pic>
         <p:nvPicPr>
           <p:cNvPr id="5" name="Picture 4" descr="Graphical user interface, application&#10;&#10;Description automatically generated">
@@ -7377,6 +7197,222 @@
               <a:t>12</a:t>
             </a:fld>
             <a:endParaRPr lang="en-GB"/>
+          </a:p>
+        </p:txBody>
+      </p:sp>
+      <p:sp>
+        <p:nvSpPr>
+          <p:cNvPr id="6" name="Content Placeholder 2">
+            <a:extLst>
+              <a:ext uri="{FF2B5EF4-FFF2-40B4-BE49-F238E27FC236}">
+                <a16:creationId xmlns:a16="http://schemas.microsoft.com/office/drawing/2014/main" id="{61E1ECC9-8857-ED63-C826-ECE52B343E8E}"/>
+              </a:ext>
+            </a:extLst>
+          </p:cNvPr>
+          <p:cNvSpPr txBox="1">
+            <a:spLocks/>
+          </p:cNvSpPr>
+          <p:nvPr/>
+        </p:nvSpPr>
+        <p:spPr>
+          <a:xfrm>
+            <a:off x="284171" y="6270339"/>
+            <a:ext cx="10969429" cy="650277"/>
+          </a:xfrm>
+          <a:prstGeom prst="rect">
+            <a:avLst/>
+          </a:prstGeom>
+        </p:spPr>
+        <p:txBody>
+          <a:bodyPr vert="horz" lIns="91440" tIns="45720" rIns="91440" bIns="45720" rtlCol="0">
+            <a:normAutofit/>
+          </a:bodyPr>
+          <a:lstStyle>
+            <a:lvl1pPr marL="342900" indent="-342900" algn="l" defTabSz="914400" rtl="0" eaLnBrk="1" latinLnBrk="0" hangingPunct="1">
+              <a:lnSpc>
+                <a:spcPct val="90000"/>
+              </a:lnSpc>
+              <a:spcBef>
+                <a:spcPts val="1000"/>
+              </a:spcBef>
+              <a:buClr>
+                <a:srgbClr val="00B050"/>
+              </a:buClr>
+              <a:buFont typeface="Wingdings" panose="05000000000000000000" pitchFamily="2" charset="2"/>
+              <a:buChar char="Ø"/>
+              <a:defRPr sz="2400" kern="1200">
+                <a:solidFill>
+                  <a:schemeClr val="tx1"/>
+                </a:solidFill>
+                <a:latin typeface="Palatino Linotype" panose="02040502050505030304" pitchFamily="18" charset="0"/>
+                <a:ea typeface="+mn-ea"/>
+                <a:cs typeface="+mn-cs"/>
+              </a:defRPr>
+            </a:lvl1pPr>
+            <a:lvl2pPr marL="685800" indent="-228600" algn="l" defTabSz="914400" rtl="0" eaLnBrk="1" latinLnBrk="0" hangingPunct="1">
+              <a:lnSpc>
+                <a:spcPct val="90000"/>
+              </a:lnSpc>
+              <a:spcBef>
+                <a:spcPts val="500"/>
+              </a:spcBef>
+              <a:buClr>
+                <a:srgbClr val="00B050"/>
+              </a:buClr>
+              <a:buFont typeface="Wingdings" panose="05000000000000000000" pitchFamily="2" charset="2"/>
+              <a:buChar char="§"/>
+              <a:defRPr sz="2000" kern="1200">
+                <a:solidFill>
+                  <a:schemeClr val="tx1"/>
+                </a:solidFill>
+                <a:latin typeface="Palatino Linotype" panose="02040502050505030304" pitchFamily="18" charset="0"/>
+                <a:ea typeface="+mn-ea"/>
+                <a:cs typeface="+mn-cs"/>
+              </a:defRPr>
+            </a:lvl2pPr>
+            <a:lvl3pPr marL="1143000" indent="-228600" algn="l" defTabSz="914400" rtl="0" eaLnBrk="1" latinLnBrk="0" hangingPunct="1">
+              <a:lnSpc>
+                <a:spcPct val="90000"/>
+              </a:lnSpc>
+              <a:spcBef>
+                <a:spcPts val="500"/>
+              </a:spcBef>
+              <a:buClr>
+                <a:srgbClr val="00B050"/>
+              </a:buClr>
+              <a:buFont typeface="Arial" panose="020B0604020202020204" pitchFamily="34" charset="0"/>
+              <a:buChar char="•"/>
+              <a:defRPr sz="1800" kern="1200">
+                <a:solidFill>
+                  <a:schemeClr val="tx1"/>
+                </a:solidFill>
+                <a:latin typeface="Palatino Linotype" panose="02040502050505030304" pitchFamily="18" charset="0"/>
+                <a:ea typeface="+mn-ea"/>
+                <a:cs typeface="+mn-cs"/>
+              </a:defRPr>
+            </a:lvl3pPr>
+            <a:lvl4pPr marL="1600200" indent="-228600" algn="l" defTabSz="914400" rtl="0" eaLnBrk="1" latinLnBrk="0" hangingPunct="1">
+              <a:lnSpc>
+                <a:spcPct val="90000"/>
+              </a:lnSpc>
+              <a:spcBef>
+                <a:spcPts val="500"/>
+              </a:spcBef>
+              <a:buClr>
+                <a:srgbClr val="00B050"/>
+              </a:buClr>
+              <a:buFont typeface="Courier New" panose="02070309020205020404" pitchFamily="49" charset="0"/>
+              <a:buChar char="o"/>
+              <a:defRPr sz="1600" kern="1200">
+                <a:solidFill>
+                  <a:schemeClr val="tx1"/>
+                </a:solidFill>
+                <a:latin typeface="Palatino Linotype" panose="02040502050505030304" pitchFamily="18" charset="0"/>
+                <a:ea typeface="+mn-ea"/>
+                <a:cs typeface="+mn-cs"/>
+              </a:defRPr>
+            </a:lvl4pPr>
+            <a:lvl5pPr marL="2057400" indent="-228600" algn="l" defTabSz="914400" rtl="0" eaLnBrk="1" latinLnBrk="0" hangingPunct="1">
+              <a:lnSpc>
+                <a:spcPct val="90000"/>
+              </a:lnSpc>
+              <a:spcBef>
+                <a:spcPts val="500"/>
+              </a:spcBef>
+              <a:buClr>
+                <a:srgbClr val="00B050"/>
+              </a:buClr>
+              <a:buFont typeface="Times New Roman" panose="02020603050405020304" pitchFamily="18" charset="0"/>
+              <a:buChar char="̶"/>
+              <a:defRPr sz="1600" kern="1200">
+                <a:solidFill>
+                  <a:schemeClr val="tx1"/>
+                </a:solidFill>
+                <a:latin typeface="Palatino Linotype" panose="02040502050505030304" pitchFamily="18" charset="0"/>
+                <a:ea typeface="+mn-ea"/>
+                <a:cs typeface="+mn-cs"/>
+              </a:defRPr>
+            </a:lvl5pPr>
+            <a:lvl6pPr marL="2514600" indent="-228600" algn="l" defTabSz="914400" rtl="0" eaLnBrk="1" latinLnBrk="0" hangingPunct="1">
+              <a:lnSpc>
+                <a:spcPct val="90000"/>
+              </a:lnSpc>
+              <a:spcBef>
+                <a:spcPts val="500"/>
+              </a:spcBef>
+              <a:buFont typeface="Arial" panose="020B0604020202020204" pitchFamily="34" charset="0"/>
+              <a:buChar char="•"/>
+              <a:defRPr sz="1800" kern="1200">
+                <a:solidFill>
+                  <a:schemeClr val="tx1"/>
+                </a:solidFill>
+                <a:latin typeface="+mn-lt"/>
+                <a:ea typeface="+mn-ea"/>
+                <a:cs typeface="+mn-cs"/>
+              </a:defRPr>
+            </a:lvl6pPr>
+            <a:lvl7pPr marL="2971800" indent="-228600" algn="l" defTabSz="914400" rtl="0" eaLnBrk="1" latinLnBrk="0" hangingPunct="1">
+              <a:lnSpc>
+                <a:spcPct val="90000"/>
+              </a:lnSpc>
+              <a:spcBef>
+                <a:spcPts val="500"/>
+              </a:spcBef>
+              <a:buFont typeface="Arial" panose="020B0604020202020204" pitchFamily="34" charset="0"/>
+              <a:buChar char="•"/>
+              <a:defRPr sz="1800" kern="1200">
+                <a:solidFill>
+                  <a:schemeClr val="tx1"/>
+                </a:solidFill>
+                <a:latin typeface="+mn-lt"/>
+                <a:ea typeface="+mn-ea"/>
+                <a:cs typeface="+mn-cs"/>
+              </a:defRPr>
+            </a:lvl7pPr>
+            <a:lvl8pPr marL="3429000" indent="-228600" algn="l" defTabSz="914400" rtl="0" eaLnBrk="1" latinLnBrk="0" hangingPunct="1">
+              <a:lnSpc>
+                <a:spcPct val="90000"/>
+              </a:lnSpc>
+              <a:spcBef>
+                <a:spcPts val="500"/>
+              </a:spcBef>
+              <a:buFont typeface="Arial" panose="020B0604020202020204" pitchFamily="34" charset="0"/>
+              <a:buChar char="•"/>
+              <a:defRPr sz="1800" kern="1200">
+                <a:solidFill>
+                  <a:schemeClr val="tx1"/>
+                </a:solidFill>
+                <a:latin typeface="+mn-lt"/>
+                <a:ea typeface="+mn-ea"/>
+                <a:cs typeface="+mn-cs"/>
+              </a:defRPr>
+            </a:lvl8pPr>
+            <a:lvl9pPr marL="3886200" indent="-228600" algn="l" defTabSz="914400" rtl="0" eaLnBrk="1" latinLnBrk="0" hangingPunct="1">
+              <a:lnSpc>
+                <a:spcPct val="90000"/>
+              </a:lnSpc>
+              <a:spcBef>
+                <a:spcPts val="500"/>
+              </a:spcBef>
+              <a:buFont typeface="Arial" panose="020B0604020202020204" pitchFamily="34" charset="0"/>
+              <a:buChar char="•"/>
+              <a:defRPr sz="1800" kern="1200">
+                <a:solidFill>
+                  <a:schemeClr val="tx1"/>
+                </a:solidFill>
+                <a:latin typeface="+mn-lt"/>
+                <a:ea typeface="+mn-ea"/>
+                <a:cs typeface="+mn-cs"/>
+              </a:defRPr>
+            </a:lvl9pPr>
+          </a:lstStyle>
+          <a:p>
+            <a:r>
+              <a:rPr lang="en-IT" dirty="0">
+                <a:latin typeface="Aptos" panose="020B0004020202020204" pitchFamily="34" charset="0"/>
+              </a:rPr>
+              <a:t>Of course, there are many others…</a:t>
+            </a:r>
           </a:p>
         </p:txBody>
       </p:sp>
@@ -7650,12 +7686,77 @@
           </a:p>
         </p:txBody>
       </p:sp>
-      <p:sp>
-        <p:nvSpPr>
-          <p:cNvPr id="9" name="Content Placeholder 2">
+      <p:pic>
+        <p:nvPicPr>
+          <p:cNvPr id="5" name="Picture 4" descr="Graphical user interface, application&#10;&#10;Description automatically generated">
             <a:extLst>
               <a:ext uri="{FF2B5EF4-FFF2-40B4-BE49-F238E27FC236}">
-                <a16:creationId xmlns:a16="http://schemas.microsoft.com/office/drawing/2014/main" id="{AC4F1A50-E1EA-F24E-B18E-60494901689B}"/>
+                <a16:creationId xmlns:a16="http://schemas.microsoft.com/office/drawing/2014/main" id="{3AE2E19E-17C6-3141-8EB4-6852CC1B50FD}"/>
+              </a:ext>
+            </a:extLst>
+          </p:cNvPr>
+          <p:cNvPicPr>
+            <a:picLocks noChangeAspect="1"/>
+          </p:cNvPicPr>
+          <p:nvPr/>
+        </p:nvPicPr>
+        <p:blipFill>
+          <a:blip r:embed="rId3">
+            <a:extLst>
+              <a:ext uri="{28A0092B-C50C-407E-A947-70E740481C1C}">
+                <a14:useLocalDpi xmlns:a14="http://schemas.microsoft.com/office/drawing/2010/main" val="0"/>
+              </a:ext>
+            </a:extLst>
+          </a:blip>
+          <a:stretch>
+            <a:fillRect/>
+          </a:stretch>
+        </p:blipFill>
+        <p:spPr>
+          <a:xfrm>
+            <a:off x="2464000" y="2148831"/>
+            <a:ext cx="7572800" cy="2994847"/>
+          </a:xfrm>
+          <a:prstGeom prst="rect">
+            <a:avLst/>
+          </a:prstGeom>
+        </p:spPr>
+      </p:pic>
+      <p:sp>
+        <p:nvSpPr>
+          <p:cNvPr id="3" name="Slide Number Placeholder 2">
+            <a:extLst>
+              <a:ext uri="{FF2B5EF4-FFF2-40B4-BE49-F238E27FC236}">
+                <a16:creationId xmlns:a16="http://schemas.microsoft.com/office/drawing/2014/main" id="{1935B66A-493D-9D40-94D6-87FAFEE320D3}"/>
+              </a:ext>
+            </a:extLst>
+          </p:cNvPr>
+          <p:cNvSpPr>
+            <a:spLocks noGrp="1"/>
+          </p:cNvSpPr>
+          <p:nvPr>
+            <p:ph type="sldNum" sz="quarter" idx="12"/>
+          </p:nvPr>
+        </p:nvSpPr>
+        <p:spPr/>
+        <p:txBody>
+          <a:bodyPr/>
+          <a:lstStyle/>
+          <a:p>
+            <a:fld id="{31DE2C5B-556E-47B8-A792-024C2FCA4ACC}" type="slidenum">
+              <a:rPr lang="en-GB" smtClean="0"/>
+              <a:t>13</a:t>
+            </a:fld>
+            <a:endParaRPr lang="en-GB"/>
+          </a:p>
+        </p:txBody>
+      </p:sp>
+      <p:sp>
+        <p:nvSpPr>
+          <p:cNvPr id="6" name="Content Placeholder 2">
+            <a:extLst>
+              <a:ext uri="{FF2B5EF4-FFF2-40B4-BE49-F238E27FC236}">
+                <a16:creationId xmlns:a16="http://schemas.microsoft.com/office/drawing/2014/main" id="{BD309966-65A8-68CF-3EF7-C4394AC1C950}"/>
               </a:ext>
             </a:extLst>
           </p:cNvPr>
@@ -7858,74 +7959,11 @@
           </a:lstStyle>
           <a:p>
             <a:r>
-              <a:rPr lang="en-IT" dirty="0"/>
+              <a:rPr lang="en-IT" dirty="0">
+                <a:latin typeface="Aptos" panose="020B0004020202020204" pitchFamily="34" charset="0"/>
+              </a:rPr>
               <a:t>Of course, there are many others…</a:t>
             </a:r>
-          </a:p>
-        </p:txBody>
-      </p:sp>
-      <p:pic>
-        <p:nvPicPr>
-          <p:cNvPr id="5" name="Picture 4" descr="Graphical user interface, application&#10;&#10;Description automatically generated">
-            <a:extLst>
-              <a:ext uri="{FF2B5EF4-FFF2-40B4-BE49-F238E27FC236}">
-                <a16:creationId xmlns:a16="http://schemas.microsoft.com/office/drawing/2014/main" id="{3AE2E19E-17C6-3141-8EB4-6852CC1B50FD}"/>
-              </a:ext>
-            </a:extLst>
-          </p:cNvPr>
-          <p:cNvPicPr>
-            <a:picLocks noChangeAspect="1"/>
-          </p:cNvPicPr>
-          <p:nvPr/>
-        </p:nvPicPr>
-        <p:blipFill>
-          <a:blip r:embed="rId3">
-            <a:extLst>
-              <a:ext uri="{28A0092B-C50C-407E-A947-70E740481C1C}">
-                <a14:useLocalDpi xmlns:a14="http://schemas.microsoft.com/office/drawing/2010/main" val="0"/>
-              </a:ext>
-            </a:extLst>
-          </a:blip>
-          <a:stretch>
-            <a:fillRect/>
-          </a:stretch>
-        </p:blipFill>
-        <p:spPr>
-          <a:xfrm>
-            <a:off x="2464000" y="2148831"/>
-            <a:ext cx="7572800" cy="2994847"/>
-          </a:xfrm>
-          <a:prstGeom prst="rect">
-            <a:avLst/>
-          </a:prstGeom>
-        </p:spPr>
-      </p:pic>
-      <p:sp>
-        <p:nvSpPr>
-          <p:cNvPr id="3" name="Slide Number Placeholder 2">
-            <a:extLst>
-              <a:ext uri="{FF2B5EF4-FFF2-40B4-BE49-F238E27FC236}">
-                <a16:creationId xmlns:a16="http://schemas.microsoft.com/office/drawing/2014/main" id="{1935B66A-493D-9D40-94D6-87FAFEE320D3}"/>
-              </a:ext>
-            </a:extLst>
-          </p:cNvPr>
-          <p:cNvSpPr>
-            <a:spLocks noGrp="1"/>
-          </p:cNvSpPr>
-          <p:nvPr>
-            <p:ph type="sldNum" sz="quarter" idx="12"/>
-          </p:nvPr>
-        </p:nvSpPr>
-        <p:spPr/>
-        <p:txBody>
-          <a:bodyPr/>
-          <a:lstStyle/>
-          <a:p>
-            <a:fld id="{31DE2C5B-556E-47B8-A792-024C2FCA4ACC}" type="slidenum">
-              <a:rPr lang="en-GB" smtClean="0"/>
-              <a:t>13</a:t>
-            </a:fld>
-            <a:endParaRPr lang="en-GB"/>
           </a:p>
         </p:txBody>
       </p:sp>
@@ -8525,7 +8563,9 @@
             </a:lvl9pPr>
           </a:lstStyle>
           <a:p>
-            <a:endParaRPr lang="en-IT" dirty="0"/>
+            <a:endParaRPr lang="en-IT" dirty="0">
+              <a:latin typeface="Aptos" panose="020B0004020202020204" pitchFamily="34" charset="0"/>
+            </a:endParaRPr>
           </a:p>
         </p:txBody>
       </p:sp>
@@ -8554,7 +8594,7 @@
         </p:spPr>
         <p:txBody>
           <a:bodyPr vert="horz" lIns="91440" tIns="45720" rIns="91440" bIns="45720" rtlCol="0">
-            <a:normAutofit fontScale="85000" lnSpcReduction="10000"/>
+            <a:normAutofit fontScale="92500" lnSpcReduction="10000"/>
           </a:bodyPr>
           <a:lstStyle>
             <a:lvl1pPr marL="342900" indent="-342900" algn="l" defTabSz="914400" rtl="0" eaLnBrk="1" latinLnBrk="0" hangingPunct="1">
@@ -8740,7 +8780,9 @@
               <a:buNone/>
             </a:pPr>
             <a:r>
-              <a:rPr lang="en-US" dirty="0"/>
+              <a:rPr lang="en-US" dirty="0">
+                <a:latin typeface="Aptos" panose="020B0004020202020204" pitchFamily="34" charset="0"/>
+              </a:rPr>
               <a:t>The set of 4 doubles: minimum and maximum height, minimum and maximum width.</a:t>
             </a:r>
           </a:p>
@@ -8957,7 +8999,9 @@
               <a:buNone/>
             </a:pPr>
             <a:r>
-              <a:rPr lang="en-US" sz="2000" dirty="0"/>
+              <a:rPr lang="en-US" sz="2000" dirty="0">
+                <a:latin typeface="Aptos" panose="020B0004020202020204" pitchFamily="34" charset="0"/>
+              </a:rPr>
               <a:t>The set of 2 doubles: height and width. </a:t>
             </a:r>
           </a:p>
@@ -9174,7 +9218,9 @@
               <a:buNone/>
             </a:pPr>
             <a:r>
-              <a:rPr lang="en-US" sz="2000" dirty="0"/>
+              <a:rPr lang="en-US" sz="2000" dirty="0">
+                <a:latin typeface="Aptos" panose="020B0004020202020204" pitchFamily="34" charset="0"/>
+              </a:rPr>
               <a:t>The set of 2 doubles: x and y.</a:t>
             </a:r>
           </a:p>
@@ -9658,7 +9704,9 @@
             </a:lvl9pPr>
           </a:lstStyle>
           <a:p>
-            <a:endParaRPr lang="en-IT" dirty="0"/>
+            <a:endParaRPr lang="en-IT" dirty="0">
+              <a:latin typeface="Aptos" panose="020B0004020202020204" pitchFamily="34" charset="0"/>
+            </a:endParaRPr>
           </a:p>
         </p:txBody>
       </p:sp>
@@ -9696,12 +9744,12 @@
           <a:p>
             <a:r>
               <a:rPr lang="en-US" sz="2400" b="1" dirty="0">
-                <a:latin typeface="Palatino Linotype" panose="02040502050505030304" pitchFamily="18" charset="0"/>
+                <a:latin typeface="Aptos" panose="020B0004020202020204" pitchFamily="34" charset="0"/>
               </a:rPr>
               <a:t>Parent</a:t>
             </a:r>
             <a:endParaRPr lang="en-IT" sz="2400" dirty="0">
-              <a:latin typeface="Palatino Linotype" panose="02040502050505030304" pitchFamily="18" charset="0"/>
+              <a:latin typeface="Aptos" panose="020B0004020202020204" pitchFamily="34" charset="0"/>
             </a:endParaRPr>
           </a:p>
         </p:txBody>
@@ -9740,12 +9788,12 @@
           <a:p>
             <a:r>
               <a:rPr lang="en-US" sz="2400" b="1" dirty="0">
-                <a:latin typeface="Palatino Linotype" panose="02040502050505030304" pitchFamily="18" charset="0"/>
+                <a:latin typeface="Aptos" panose="020B0004020202020204" pitchFamily="34" charset="0"/>
               </a:rPr>
               <a:t>Widget</a:t>
             </a:r>
             <a:endParaRPr lang="en-IT" sz="2400" dirty="0">
-              <a:latin typeface="Palatino Linotype" panose="02040502050505030304" pitchFamily="18" charset="0"/>
+              <a:latin typeface="Aptos" panose="020B0004020202020204" pitchFamily="34" charset="0"/>
             </a:endParaRPr>
           </a:p>
         </p:txBody>
@@ -9784,12 +9832,12 @@
           <a:p>
             <a:r>
               <a:rPr lang="en-US" sz="2400" b="1" dirty="0">
-                <a:latin typeface="Palatino Linotype" panose="02040502050505030304" pitchFamily="18" charset="0"/>
+                <a:latin typeface="Aptos" panose="020B0004020202020204" pitchFamily="34" charset="0"/>
               </a:rPr>
               <a:t>Children</a:t>
             </a:r>
             <a:endParaRPr lang="en-IT" sz="2400" dirty="0">
-              <a:latin typeface="Palatino Linotype" panose="02040502050505030304" pitchFamily="18" charset="0"/>
+              <a:latin typeface="Aptos" panose="020B0004020202020204" pitchFamily="34" charset="0"/>
             </a:endParaRPr>
           </a:p>
         </p:txBody>
@@ -10097,62 +10145,92 @@
               <a:buFont typeface="Wingdings" panose="05000000000000000000" pitchFamily="2" charset="2"/>
               <a:buNone/>
             </a:pPr>
-            <a:endParaRPr lang="en-US" sz="3200" b="1" dirty="0"/>
-          </a:p>
-          <a:p>
-            <a:r>
-              <a:rPr lang="en-US" dirty="0"/>
+            <a:endParaRPr lang="en-US" sz="3200" b="1" dirty="0">
+              <a:latin typeface="Aptos" panose="020B0004020202020204" pitchFamily="34" charset="0"/>
+            </a:endParaRPr>
+          </a:p>
+          <a:p>
+            <a:r>
+              <a:rPr lang="en-US" dirty="0">
+                <a:latin typeface="Aptos" panose="020B0004020202020204" pitchFamily="34" charset="0"/>
+              </a:rPr>
               <a:t>A widget gets its constraints from its parent and tells its children what are the constraints (i.e., “</a:t>
             </a:r>
             <a:r>
-              <a:rPr lang="en-US" b="1" dirty="0"/>
+              <a:rPr lang="en-US" b="1" dirty="0">
+                <a:latin typeface="Aptos" panose="020B0004020202020204" pitchFamily="34" charset="0"/>
+              </a:rPr>
               <a:t>constraints go down</a:t>
             </a:r>
             <a:r>
-              <a:rPr lang="en-US" dirty="0"/>
+              <a:rPr lang="en-US" dirty="0">
+                <a:latin typeface="Aptos" panose="020B0004020202020204" pitchFamily="34" charset="0"/>
+              </a:rPr>
               <a:t>”).</a:t>
             </a:r>
           </a:p>
           <a:p>
-            <a:endParaRPr lang="en-US" dirty="0"/>
-          </a:p>
-          <a:p>
-            <a:r>
-              <a:rPr lang="en-US" dirty="0"/>
+            <a:endParaRPr lang="en-US" dirty="0">
+              <a:latin typeface="Aptos" panose="020B0004020202020204" pitchFamily="34" charset="0"/>
+            </a:endParaRPr>
+          </a:p>
+          <a:p>
+            <a:r>
+              <a:rPr lang="en-US" dirty="0">
+                <a:latin typeface="Aptos" panose="020B0004020202020204" pitchFamily="34" charset="0"/>
+              </a:rPr>
               <a:t>A widget then asks its children the sizes they want to be (i.e., “</a:t>
             </a:r>
             <a:r>
-              <a:rPr lang="en-US" b="1" dirty="0"/>
+              <a:rPr lang="en-US" b="1" dirty="0">
+                <a:latin typeface="Aptos" panose="020B0004020202020204" pitchFamily="34" charset="0"/>
+              </a:rPr>
               <a:t>sizes go up</a:t>
             </a:r>
             <a:r>
-              <a:rPr lang="en-US" dirty="0"/>
+              <a:rPr lang="en-US" dirty="0">
+                <a:latin typeface="Aptos" panose="020B0004020202020204" pitchFamily="34" charset="0"/>
+              </a:rPr>
               <a:t>”).</a:t>
             </a:r>
           </a:p>
           <a:p>
-            <a:endParaRPr lang="en-US" dirty="0"/>
-          </a:p>
-          <a:p>
-            <a:r>
-              <a:rPr lang="en-US" dirty="0"/>
+            <a:endParaRPr lang="en-US" dirty="0">
+              <a:latin typeface="Aptos" panose="020B0004020202020204" pitchFamily="34" charset="0"/>
+            </a:endParaRPr>
+          </a:p>
+          <a:p>
+            <a:r>
+              <a:rPr lang="en-US" dirty="0">
+                <a:latin typeface="Aptos" panose="020B0004020202020204" pitchFamily="34" charset="0"/>
+              </a:rPr>
               <a:t>A widget positions its children (i.e., “</a:t>
             </a:r>
             <a:r>
-              <a:rPr lang="en-US" b="1" dirty="0"/>
+              <a:rPr lang="en-US" b="1" dirty="0">
+                <a:latin typeface="Aptos" panose="020B0004020202020204" pitchFamily="34" charset="0"/>
+              </a:rPr>
               <a:t>parent sets position</a:t>
             </a:r>
             <a:r>
-              <a:rPr lang="en-US" dirty="0"/>
+              <a:rPr lang="en-US" dirty="0">
+                <a:latin typeface="Aptos" panose="020B0004020202020204" pitchFamily="34" charset="0"/>
+              </a:rPr>
               <a:t>”).</a:t>
             </a:r>
-            <a:endParaRPr lang="en-IT" dirty="0"/>
-          </a:p>
-          <a:p>
-            <a:endParaRPr lang="en-IT" dirty="0"/>
-          </a:p>
-          <a:p>
-            <a:endParaRPr lang="en-IT" dirty="0"/>
+            <a:endParaRPr lang="en-IT" dirty="0">
+              <a:latin typeface="Aptos" panose="020B0004020202020204" pitchFamily="34" charset="0"/>
+            </a:endParaRPr>
+          </a:p>
+          <a:p>
+            <a:endParaRPr lang="en-IT" dirty="0">
+              <a:latin typeface="Aptos" panose="020B0004020202020204" pitchFamily="34" charset="0"/>
+            </a:endParaRPr>
+          </a:p>
+          <a:p>
+            <a:endParaRPr lang="en-IT" dirty="0">
+              <a:latin typeface="Aptos" panose="020B0004020202020204" pitchFamily="34" charset="0"/>
+            </a:endParaRPr>
           </a:p>
         </p:txBody>
       </p:sp>
@@ -10208,7 +10286,7 @@
             <a:pPr algn="ctr"/>
             <a:r>
               <a:rPr lang="en-IT" dirty="0">
-                <a:latin typeface="Palatino Linotype" panose="02040502050505030304" pitchFamily="18" charset="0"/>
+                <a:latin typeface="Aptos" panose="020B0004020202020204" pitchFamily="34" charset="0"/>
               </a:rPr>
               <a:t>SIZES</a:t>
             </a:r>
@@ -10267,7 +10345,7 @@
             <a:pPr algn="ctr"/>
             <a:r>
               <a:rPr lang="en-IT" dirty="0">
-                <a:latin typeface="Palatino Linotype" panose="02040502050505030304" pitchFamily="18" charset="0"/>
+                <a:latin typeface="Aptos" panose="020B0004020202020204" pitchFamily="34" charset="0"/>
               </a:rPr>
               <a:t>POS.</a:t>
             </a:r>
@@ -10326,7 +10404,7 @@
             <a:pPr algn="ctr"/>
             <a:r>
               <a:rPr lang="en-IT" dirty="0">
-                <a:latin typeface="Palatino Linotype" panose="02040502050505030304" pitchFamily="18" charset="0"/>
+                <a:latin typeface="Aptos" panose="020B0004020202020204" pitchFamily="34" charset="0"/>
               </a:rPr>
               <a:t>CONSTRAINTS</a:t>
             </a:r>
@@ -10385,7 +10463,7 @@
             <a:pPr algn="ctr"/>
             <a:r>
               <a:rPr lang="en-IT" dirty="0">
-                <a:latin typeface="Palatino Linotype" panose="02040502050505030304" pitchFamily="18" charset="0"/>
+                <a:latin typeface="Aptos" panose="020B0004020202020204" pitchFamily="34" charset="0"/>
               </a:rPr>
               <a:t>POS.</a:t>
             </a:r>
@@ -10687,7 +10765,9 @@
             </a:lvl9pPr>
           </a:lstStyle>
           <a:p>
-            <a:endParaRPr lang="en-IT" dirty="0"/>
+            <a:endParaRPr lang="en-IT" dirty="0">
+              <a:latin typeface="Aptos" panose="020B0004020202020204" pitchFamily="34" charset="0"/>
+            </a:endParaRPr>
           </a:p>
         </p:txBody>
       </p:sp>
@@ -10725,12 +10805,12 @@
           <a:p>
             <a:r>
               <a:rPr lang="en-US" sz="2400" b="1" dirty="0">
-                <a:latin typeface="Palatino Linotype" panose="02040502050505030304" pitchFamily="18" charset="0"/>
+                <a:latin typeface="Aptos" panose="020B0004020202020204" pitchFamily="34" charset="0"/>
               </a:rPr>
               <a:t>Parent</a:t>
             </a:r>
             <a:endParaRPr lang="en-IT" sz="2400" dirty="0">
-              <a:latin typeface="Palatino Linotype" panose="02040502050505030304" pitchFamily="18" charset="0"/>
+              <a:latin typeface="Aptos" panose="020B0004020202020204" pitchFamily="34" charset="0"/>
             </a:endParaRPr>
           </a:p>
         </p:txBody>
@@ -10769,12 +10849,12 @@
           <a:p>
             <a:r>
               <a:rPr lang="en-US" sz="2400" b="1" dirty="0">
-                <a:latin typeface="Palatino Linotype" panose="02040502050505030304" pitchFamily="18" charset="0"/>
+                <a:latin typeface="Aptos" panose="020B0004020202020204" pitchFamily="34" charset="0"/>
               </a:rPr>
               <a:t>Widget</a:t>
             </a:r>
             <a:endParaRPr lang="en-IT" sz="2400" dirty="0">
-              <a:latin typeface="Palatino Linotype" panose="02040502050505030304" pitchFamily="18" charset="0"/>
+              <a:latin typeface="Aptos" panose="020B0004020202020204" pitchFamily="34" charset="0"/>
             </a:endParaRPr>
           </a:p>
         </p:txBody>
@@ -10813,12 +10893,12 @@
           <a:p>
             <a:r>
               <a:rPr lang="en-US" sz="2400" b="1" dirty="0">
-                <a:latin typeface="Palatino Linotype" panose="02040502050505030304" pitchFamily="18" charset="0"/>
+                <a:latin typeface="Aptos" panose="020B0004020202020204" pitchFamily="34" charset="0"/>
               </a:rPr>
               <a:t>Children</a:t>
             </a:r>
             <a:endParaRPr lang="en-IT" sz="2400" dirty="0">
-              <a:latin typeface="Palatino Linotype" panose="02040502050505030304" pitchFamily="18" charset="0"/>
+              <a:latin typeface="Aptos" panose="020B0004020202020204" pitchFamily="34" charset="0"/>
             </a:endParaRPr>
           </a:p>
         </p:txBody>
@@ -11123,101 +11203,141 @@
           </a:lstStyle>
           <a:p>
             <a:r>
-              <a:rPr lang="en-GB" b="1" dirty="0"/>
+              <a:rPr lang="en-GB" b="1" dirty="0">
+                <a:latin typeface="Aptos" panose="020B0004020202020204" pitchFamily="34" charset="0"/>
+              </a:rPr>
               <a:t>Widget</a:t>
             </a:r>
             <a:r>
-              <a:rPr lang="en-GB" dirty="0"/>
+              <a:rPr lang="en-GB" dirty="0">
+                <a:latin typeface="Aptos" panose="020B0004020202020204" pitchFamily="34" charset="0"/>
+              </a:rPr>
               <a:t>: “Hey parent, what are my constraints?”</a:t>
             </a:r>
           </a:p>
           <a:p>
             <a:r>
-              <a:rPr lang="en-GB" b="1" dirty="0"/>
+              <a:rPr lang="en-GB" b="1" dirty="0">
+                <a:latin typeface="Aptos" panose="020B0004020202020204" pitchFamily="34" charset="0"/>
+              </a:rPr>
               <a:t>Parent</a:t>
             </a:r>
             <a:r>
-              <a:rPr lang="en-GB" dirty="0"/>
+              <a:rPr lang="en-GB" dirty="0">
+                <a:latin typeface="Aptos" panose="020B0004020202020204" pitchFamily="34" charset="0"/>
+              </a:rPr>
               <a:t>: “You must be from 80 to 300 pixels wide, and 30 to 85 tall.”</a:t>
             </a:r>
           </a:p>
           <a:p>
             <a:r>
-              <a:rPr lang="en-GB" b="1" dirty="0"/>
+              <a:rPr lang="en-GB" b="1" dirty="0">
+                <a:latin typeface="Aptos" panose="020B0004020202020204" pitchFamily="34" charset="0"/>
+              </a:rPr>
               <a:t>Widget</a:t>
             </a:r>
             <a:r>
-              <a:rPr lang="en-GB" dirty="0"/>
+              <a:rPr lang="en-GB" dirty="0">
+                <a:latin typeface="Aptos" panose="020B0004020202020204" pitchFamily="34" charset="0"/>
+              </a:rPr>
               <a:t>: “Since I want to have 5 pixels of padding, then my children can have at most 290 pixels of width and 75 pixels of height.”</a:t>
             </a:r>
           </a:p>
           <a:p>
             <a:r>
-              <a:rPr lang="en-GB" b="1" dirty="0"/>
+              <a:rPr lang="en-GB" b="1" dirty="0">
+                <a:latin typeface="Aptos" panose="020B0004020202020204" pitchFamily="34" charset="0"/>
+              </a:rPr>
               <a:t>Widget</a:t>
             </a:r>
             <a:r>
-              <a:rPr lang="en-GB" dirty="0"/>
+              <a:rPr lang="en-GB" dirty="0">
+                <a:latin typeface="Aptos" panose="020B0004020202020204" pitchFamily="34" charset="0"/>
+              </a:rPr>
               <a:t>: “Hey first child, you must be from 0 to 290 pixels wide, and 0 to 75 tall.”</a:t>
             </a:r>
           </a:p>
           <a:p>
             <a:r>
-              <a:rPr lang="en-GB" b="1" dirty="0"/>
+              <a:rPr lang="en-GB" b="1" dirty="0">
+                <a:latin typeface="Aptos" panose="020B0004020202020204" pitchFamily="34" charset="0"/>
+              </a:rPr>
               <a:t>First child</a:t>
             </a:r>
             <a:r>
-              <a:rPr lang="en-GB" dirty="0"/>
+              <a:rPr lang="en-GB" dirty="0">
+                <a:latin typeface="Aptos" panose="020B0004020202020204" pitchFamily="34" charset="0"/>
+              </a:rPr>
               <a:t>: “OK, then I wish to be 290 pixels wide, and 20 pixels tall.”</a:t>
             </a:r>
           </a:p>
           <a:p>
             <a:r>
-              <a:rPr lang="en-GB" b="1" dirty="0"/>
+              <a:rPr lang="en-GB" b="1" dirty="0">
+                <a:latin typeface="Aptos" panose="020B0004020202020204" pitchFamily="34" charset="0"/>
+              </a:rPr>
               <a:t>Widget</a:t>
             </a:r>
             <a:r>
-              <a:rPr lang="en-GB" dirty="0"/>
+              <a:rPr lang="en-GB" dirty="0">
+                <a:latin typeface="Aptos" panose="020B0004020202020204" pitchFamily="34" charset="0"/>
+              </a:rPr>
               <a:t>: “Since I want to put my second child below the first one, this leaves only 55 pixels of height for my second child.”</a:t>
             </a:r>
           </a:p>
           <a:p>
             <a:r>
-              <a:rPr lang="en-GB" b="1" dirty="0"/>
+              <a:rPr lang="en-GB" b="1" dirty="0">
+                <a:latin typeface="Aptos" panose="020B0004020202020204" pitchFamily="34" charset="0"/>
+              </a:rPr>
               <a:t>Widget</a:t>
             </a:r>
             <a:r>
-              <a:rPr lang="en-GB" dirty="0"/>
+              <a:rPr lang="en-GB" dirty="0">
+                <a:latin typeface="Aptos" panose="020B0004020202020204" pitchFamily="34" charset="0"/>
+              </a:rPr>
               <a:t>: “Hey second child, You must be from 0 to 290 wide, and 0 to 55 tall.”</a:t>
             </a:r>
           </a:p>
           <a:p>
             <a:r>
-              <a:rPr lang="en-GB" b="1" dirty="0"/>
+              <a:rPr lang="en-GB" b="1" dirty="0">
+                <a:latin typeface="Aptos" panose="020B0004020202020204" pitchFamily="34" charset="0"/>
+              </a:rPr>
               <a:t>Second child</a:t>
             </a:r>
             <a:r>
-              <a:rPr lang="en-GB" dirty="0"/>
+              <a:rPr lang="en-GB" dirty="0">
+                <a:latin typeface="Aptos" panose="020B0004020202020204" pitchFamily="34" charset="0"/>
+              </a:rPr>
               <a:t>: “OK, I wish to be 140 pixels wide, and 30 pixels tall.”</a:t>
             </a:r>
           </a:p>
           <a:p>
             <a:r>
-              <a:rPr lang="en-GB" b="1" dirty="0"/>
+              <a:rPr lang="en-GB" b="1" dirty="0">
+                <a:latin typeface="Aptos" panose="020B0004020202020204" pitchFamily="34" charset="0"/>
+              </a:rPr>
               <a:t>Widget</a:t>
             </a:r>
             <a:r>
-              <a:rPr lang="en-GB" dirty="0"/>
+              <a:rPr lang="en-GB" dirty="0">
+                <a:latin typeface="Aptos" panose="020B0004020202020204" pitchFamily="34" charset="0"/>
+              </a:rPr>
               <a:t>: “Very well. My first child has position x: 5 and y: 5, and my second child has x: 80 and y: 25.”</a:t>
             </a:r>
           </a:p>
           <a:p>
             <a:r>
-              <a:rPr lang="en-GB" b="1" dirty="0"/>
+              <a:rPr lang="en-GB" b="1" dirty="0">
+                <a:latin typeface="Aptos" panose="020B0004020202020204" pitchFamily="34" charset="0"/>
+              </a:rPr>
               <a:t>Widget</a:t>
             </a:r>
             <a:r>
-              <a:rPr lang="en-GB" dirty="0"/>
+              <a:rPr lang="en-GB" dirty="0">
+                <a:latin typeface="Aptos" panose="020B0004020202020204" pitchFamily="34" charset="0"/>
+              </a:rPr>
               <a:t>: “Hey parent, I’ve decided that my size is going to be 300 pixels wide, and 60 pixels tall.”</a:t>
             </a:r>
           </a:p>
@@ -11275,7 +11395,7 @@
             <a:pPr algn="ctr"/>
             <a:r>
               <a:rPr lang="en-IT" dirty="0">
-                <a:latin typeface="Palatino Linotype" panose="02040502050505030304" pitchFamily="18" charset="0"/>
+                <a:latin typeface="Aptos" panose="020B0004020202020204" pitchFamily="34" charset="0"/>
               </a:rPr>
               <a:t>SIZES</a:t>
             </a:r>
@@ -11334,7 +11454,7 @@
             <a:pPr algn="ctr"/>
             <a:r>
               <a:rPr lang="en-IT" dirty="0">
-                <a:latin typeface="Palatino Linotype" panose="02040502050505030304" pitchFamily="18" charset="0"/>
+                <a:latin typeface="Aptos" panose="020B0004020202020204" pitchFamily="34" charset="0"/>
               </a:rPr>
               <a:t>POS.</a:t>
             </a:r>
@@ -11393,7 +11513,7 @@
             <a:pPr algn="ctr"/>
             <a:r>
               <a:rPr lang="en-IT" dirty="0">
-                <a:latin typeface="Palatino Linotype" panose="02040502050505030304" pitchFamily="18" charset="0"/>
+                <a:latin typeface="Aptos" panose="020B0004020202020204" pitchFamily="34" charset="0"/>
               </a:rPr>
               <a:t>CONSTRAINTS</a:t>
             </a:r>
@@ -11452,7 +11572,7 @@
             <a:pPr algn="ctr"/>
             <a:r>
               <a:rPr lang="en-IT" dirty="0">
-                <a:latin typeface="Palatino Linotype" panose="02040502050505030304" pitchFamily="18" charset="0"/>
+                <a:latin typeface="Aptos" panose="020B0004020202020204" pitchFamily="34" charset="0"/>
               </a:rPr>
               <a:t>POS.</a:t>
             </a:r>
@@ -11783,7 +11903,9 @@
             </a:lvl9pPr>
           </a:lstStyle>
           <a:p>
-            <a:endParaRPr lang="en-IT" dirty="0"/>
+            <a:endParaRPr lang="en-IT" dirty="0">
+              <a:latin typeface="Aptos" panose="020B0004020202020204" pitchFamily="34" charset="0"/>
+            </a:endParaRPr>
           </a:p>
         </p:txBody>
       </p:sp>
@@ -11995,58 +12117,84 @@
           </a:lstStyle>
           <a:p>
             <a:r>
-              <a:rPr lang="en-GB" dirty="0"/>
+              <a:rPr lang="en-GB" dirty="0">
+                <a:latin typeface="Aptos" panose="020B0004020202020204" pitchFamily="34" charset="0"/>
+              </a:rPr>
               <a:t>A widget can decide its own size only within the constraints given to it by its parent: a widget </a:t>
             </a:r>
             <a:r>
-              <a:rPr lang="en-GB" b="1" dirty="0"/>
+              <a:rPr lang="en-GB" b="1" dirty="0">
+                <a:latin typeface="Aptos" panose="020B0004020202020204" pitchFamily="34" charset="0"/>
+              </a:rPr>
               <a:t>can’t have any size it wants</a:t>
             </a:r>
             <a:r>
-              <a:rPr lang="en-GB" dirty="0"/>
+              <a:rPr lang="en-GB" dirty="0">
+                <a:latin typeface="Aptos" panose="020B0004020202020204" pitchFamily="34" charset="0"/>
+              </a:rPr>
               <a:t>.</a:t>
             </a:r>
           </a:p>
           <a:p>
-            <a:endParaRPr lang="en-GB" dirty="0"/>
-          </a:p>
-          <a:p>
-            <a:r>
-              <a:rPr lang="en-GB" dirty="0"/>
+            <a:endParaRPr lang="en-GB" dirty="0">
+              <a:latin typeface="Aptos" panose="020B0004020202020204" pitchFamily="34" charset="0"/>
+            </a:endParaRPr>
+          </a:p>
+          <a:p>
+            <a:r>
+              <a:rPr lang="en-GB" dirty="0">
+                <a:latin typeface="Aptos" panose="020B0004020202020204" pitchFamily="34" charset="0"/>
+              </a:rPr>
               <a:t>A widget </a:t>
             </a:r>
             <a:r>
-              <a:rPr lang="en-GB" b="1" dirty="0"/>
+              <a:rPr lang="en-GB" b="1" dirty="0">
+                <a:latin typeface="Aptos" panose="020B0004020202020204" pitchFamily="34" charset="0"/>
+              </a:rPr>
               <a:t>can’t know and doesn’t decide its own position in the screen</a:t>
             </a:r>
             <a:r>
-              <a:rPr lang="en-GB" dirty="0"/>
+              <a:rPr lang="en-GB" dirty="0">
+                <a:latin typeface="Aptos" panose="020B0004020202020204" pitchFamily="34" charset="0"/>
+              </a:rPr>
               <a:t>.</a:t>
             </a:r>
           </a:p>
           <a:p>
-            <a:endParaRPr lang="en-GB" dirty="0"/>
-          </a:p>
-          <a:p>
-            <a:r>
-              <a:rPr lang="en-GB" dirty="0"/>
+            <a:endParaRPr lang="en-GB" dirty="0">
+              <a:latin typeface="Aptos" panose="020B0004020202020204" pitchFamily="34" charset="0"/>
+            </a:endParaRPr>
+          </a:p>
+          <a:p>
+            <a:r>
+              <a:rPr lang="en-GB" dirty="0">
+                <a:latin typeface="Aptos" panose="020B0004020202020204" pitchFamily="34" charset="0"/>
+              </a:rPr>
               <a:t>It’s impossible to precisely define the size and position of any widget without taking into consideration the tree as a whole.</a:t>
             </a:r>
           </a:p>
           <a:p>
-            <a:endParaRPr lang="en-GB" dirty="0"/>
-          </a:p>
-          <a:p>
-            <a:r>
-              <a:rPr lang="en-GB" dirty="0"/>
+            <a:endParaRPr lang="en-GB" dirty="0">
+              <a:latin typeface="Aptos" panose="020B0004020202020204" pitchFamily="34" charset="0"/>
+            </a:endParaRPr>
+          </a:p>
+          <a:p>
+            <a:r>
+              <a:rPr lang="en-GB" dirty="0">
+                <a:latin typeface="Aptos" panose="020B0004020202020204" pitchFamily="34" charset="0"/>
+              </a:rPr>
               <a:t>If a child wants a different size from its parent and the parent doesn’t have enough information to align it, then </a:t>
             </a:r>
             <a:r>
-              <a:rPr lang="en-GB" b="1" dirty="0"/>
+              <a:rPr lang="en-GB" b="1" dirty="0">
+                <a:latin typeface="Aptos" panose="020B0004020202020204" pitchFamily="34" charset="0"/>
+              </a:rPr>
               <a:t>the child’s size might be ignored</a:t>
             </a:r>
             <a:r>
-              <a:rPr lang="en-GB" dirty="0"/>
+              <a:rPr lang="en-GB" dirty="0">
+                <a:latin typeface="Aptos" panose="020B0004020202020204" pitchFamily="34" charset="0"/>
+              </a:rPr>
               <a:t>.</a:t>
             </a:r>
           </a:p>
@@ -12086,12 +12234,12 @@
           <a:p>
             <a:r>
               <a:rPr lang="en-US" sz="2400" b="1" dirty="0">
-                <a:latin typeface="Palatino Linotype" panose="02040502050505030304" pitchFamily="18" charset="0"/>
+                <a:latin typeface="Aptos" panose="020B0004020202020204" pitchFamily="34" charset="0"/>
               </a:rPr>
               <a:t>Parent</a:t>
             </a:r>
             <a:endParaRPr lang="en-IT" sz="2400" dirty="0">
-              <a:latin typeface="Palatino Linotype" panose="02040502050505030304" pitchFamily="18" charset="0"/>
+              <a:latin typeface="Aptos" panose="020B0004020202020204" pitchFamily="34" charset="0"/>
             </a:endParaRPr>
           </a:p>
         </p:txBody>
@@ -12130,12 +12278,12 @@
           <a:p>
             <a:r>
               <a:rPr lang="en-US" sz="2400" b="1" dirty="0">
-                <a:latin typeface="Palatino Linotype" panose="02040502050505030304" pitchFamily="18" charset="0"/>
+                <a:latin typeface="Aptos" panose="020B0004020202020204" pitchFamily="34" charset="0"/>
               </a:rPr>
               <a:t>Widget</a:t>
             </a:r>
             <a:endParaRPr lang="en-IT" sz="2400" dirty="0">
-              <a:latin typeface="Palatino Linotype" panose="02040502050505030304" pitchFamily="18" charset="0"/>
+              <a:latin typeface="Aptos" panose="020B0004020202020204" pitchFamily="34" charset="0"/>
             </a:endParaRPr>
           </a:p>
         </p:txBody>
@@ -12174,12 +12322,12 @@
           <a:p>
             <a:r>
               <a:rPr lang="en-US" sz="2400" b="1" dirty="0">
-                <a:latin typeface="Palatino Linotype" panose="02040502050505030304" pitchFamily="18" charset="0"/>
+                <a:latin typeface="Aptos" panose="020B0004020202020204" pitchFamily="34" charset="0"/>
               </a:rPr>
               <a:t>Children</a:t>
             </a:r>
             <a:endParaRPr lang="en-IT" sz="2400" dirty="0">
-              <a:latin typeface="Palatino Linotype" panose="02040502050505030304" pitchFamily="18" charset="0"/>
+              <a:latin typeface="Aptos" panose="020B0004020202020204" pitchFamily="34" charset="0"/>
             </a:endParaRPr>
           </a:p>
         </p:txBody>
@@ -12328,7 +12476,7 @@
             <a:pPr algn="ctr"/>
             <a:r>
               <a:rPr lang="en-IT" dirty="0">
-                <a:latin typeface="Palatino Linotype" panose="02040502050505030304" pitchFamily="18" charset="0"/>
+                <a:latin typeface="Aptos" panose="020B0004020202020204" pitchFamily="34" charset="0"/>
               </a:rPr>
               <a:t>SIZES</a:t>
             </a:r>
@@ -12387,7 +12535,7 @@
             <a:pPr algn="ctr"/>
             <a:r>
               <a:rPr lang="en-IT" dirty="0">
-                <a:latin typeface="Palatino Linotype" panose="02040502050505030304" pitchFamily="18" charset="0"/>
+                <a:latin typeface="Aptos" panose="020B0004020202020204" pitchFamily="34" charset="0"/>
               </a:rPr>
               <a:t>POS.</a:t>
             </a:r>
@@ -12446,7 +12594,7 @@
             <a:pPr algn="ctr"/>
             <a:r>
               <a:rPr lang="en-IT" dirty="0">
-                <a:latin typeface="Palatino Linotype" panose="02040502050505030304" pitchFamily="18" charset="0"/>
+                <a:latin typeface="Aptos" panose="020B0004020202020204" pitchFamily="34" charset="0"/>
               </a:rPr>
               <a:t>CONSTRAINTS</a:t>
             </a:r>
@@ -12505,7 +12653,7 @@
             <a:pPr algn="ctr"/>
             <a:r>
               <a:rPr lang="en-IT" dirty="0">
-                <a:latin typeface="Palatino Linotype" panose="02040502050505030304" pitchFamily="18" charset="0"/>
+                <a:latin typeface="Aptos" panose="020B0004020202020204" pitchFamily="34" charset="0"/>
               </a:rPr>
               <a:t>POS.</a:t>
             </a:r>
@@ -13509,26 +13657,35 @@
           </a:lstStyle>
           <a:p>
             <a:r>
-              <a:rPr lang="en-GB" dirty="0"/>
+              <a:rPr lang="en-GB" dirty="0">
+                <a:latin typeface="Aptos" panose="020B0004020202020204" pitchFamily="34" charset="0"/>
+              </a:rPr>
               <a:t>In the “Understanding constraints” article by Marcelo Glasberg </a:t>
             </a:r>
             <a:r>
               <a:rPr lang="en-GB" dirty="0">
+                <a:latin typeface="Aptos" panose="020B0004020202020204" pitchFamily="34" charset="0"/>
                 <a:hlinkClick r:id="rId3"/>
               </a:rPr>
               <a:t>https://docs.flutter.dev/development/ui/layout/constraints</a:t>
             </a:r>
             <a:r>
-              <a:rPr lang="en-GB" dirty="0"/>
+              <a:rPr lang="en-GB" dirty="0">
+                <a:latin typeface="Aptos" panose="020B0004020202020204" pitchFamily="34" charset="0"/>
+              </a:rPr>
               <a:t> (you will also find the link in the Resources section of this presentation) there are a lot (29) of examples explaining how all of this works.</a:t>
             </a:r>
           </a:p>
           <a:p>
-            <a:endParaRPr lang="en-GB" dirty="0"/>
-          </a:p>
-          <a:p>
-            <a:r>
-              <a:rPr lang="en-GB" dirty="0"/>
+            <a:endParaRPr lang="en-GB" dirty="0">
+              <a:latin typeface="Aptos" panose="020B0004020202020204" pitchFamily="34" charset="0"/>
+            </a:endParaRPr>
+          </a:p>
+          <a:p>
+            <a:r>
+              <a:rPr lang="en-GB" dirty="0">
+                <a:latin typeface="Aptos" panose="020B0004020202020204" pitchFamily="34" charset="0"/>
+              </a:rPr>
               <a:t>Let’s report the most interesting ones.</a:t>
             </a:r>
           </a:p>
@@ -13536,13 +13693,17 @@
             <a:pPr marL="0" indent="0">
               <a:buNone/>
             </a:pPr>
-            <a:endParaRPr lang="en-GB" dirty="0"/>
+            <a:endParaRPr lang="en-GB" dirty="0">
+              <a:latin typeface="Aptos" panose="020B0004020202020204" pitchFamily="34" charset="0"/>
+            </a:endParaRPr>
           </a:p>
           <a:p>
             <a:pPr marL="0" indent="0">
               <a:buNone/>
             </a:pPr>
-            <a:endParaRPr lang="en-GB" dirty="0"/>
+            <a:endParaRPr lang="en-GB" dirty="0">
+              <a:latin typeface="Aptos" panose="020B0004020202020204" pitchFamily="34" charset="0"/>
+            </a:endParaRPr>
           </a:p>
         </p:txBody>
       </p:sp>
@@ -14100,8 +14261,30 @@
           </a:p>
           <a:p>
             <a:r>
-              <a:rPr lang="en-GB" dirty="0"/>
-              <a:t>The screen is the parent of the </a:t>
+              <a:rPr lang="en-GB" dirty="0">
+                <a:latin typeface="Aptos" panose="020B0004020202020204" pitchFamily="34" charset="0"/>
+              </a:rPr>
+              <a:t>The screen is the parent of the Container, and it forces the </a:t>
+            </a:r>
+            <a:r>
+              <a:rPr lang="en-GB" dirty="0">
+                <a:latin typeface="Courier" pitchFamily="2" charset="0"/>
+              </a:rPr>
+              <a:t>Container </a:t>
+            </a:r>
+            <a:r>
+              <a:rPr lang="en-GB" dirty="0">
+                <a:latin typeface="Aptos" panose="020B0004020202020204" pitchFamily="34" charset="0"/>
+              </a:rPr>
+              <a:t>to be exactly the same size as the screen.</a:t>
+            </a:r>
+          </a:p>
+          <a:p>
+            <a:r>
+              <a:rPr lang="en-GB" dirty="0">
+                <a:latin typeface="Aptos" panose="020B0004020202020204" pitchFamily="34" charset="0"/>
+              </a:rPr>
+              <a:t>So the </a:t>
             </a:r>
             <a:r>
               <a:rPr lang="en-GB" dirty="0">
@@ -14110,33 +14293,9 @@
               <a:t>Container</a:t>
             </a:r>
             <a:r>
-              <a:rPr lang="en-GB" dirty="0"/>
-              <a:t>, and it forces the </a:t>
-            </a:r>
-            <a:r>
-              <a:rPr lang="en-GB" dirty="0">
-                <a:latin typeface="Courier" pitchFamily="2" charset="0"/>
-              </a:rPr>
-              <a:t>Container </a:t>
-            </a:r>
-            <a:r>
-              <a:rPr lang="en-GB" dirty="0"/>
-              <a:t>to be exactly the same size as the screen.</a:t>
-            </a:r>
-          </a:p>
-          <a:p>
-            <a:r>
-              <a:rPr lang="en-GB" dirty="0"/>
-              <a:t>So the </a:t>
-            </a:r>
-            <a:r>
-              <a:rPr lang="en-GB" dirty="0">
-                <a:latin typeface="Courier" pitchFamily="2" charset="0"/>
-              </a:rPr>
-              <a:t>Container</a:t>
-            </a:r>
-            <a:r>
-              <a:rPr lang="en-GB" dirty="0"/>
+              <a:rPr lang="en-GB" dirty="0">
+                <a:latin typeface="Aptos" panose="020B0004020202020204" pitchFamily="34" charset="0"/>
+              </a:rPr>
               <a:t> fills the screen and paints it red.</a:t>
             </a:r>
           </a:p>
@@ -14144,7 +14303,9 @@
             <a:pPr marL="0" indent="0">
               <a:buNone/>
             </a:pPr>
-            <a:endParaRPr lang="en-GB" dirty="0"/>
+            <a:endParaRPr lang="en-GB" dirty="0">
+              <a:latin typeface="Aptos" panose="020B0004020202020204" pitchFamily="34" charset="0"/>
+            </a:endParaRPr>
           </a:p>
           <a:p>
             <a:pPr marL="0" indent="0">
@@ -14721,36 +14882,48 @@
           </a:p>
           <a:p>
             <a:r>
-              <a:rPr lang="en-GB" dirty="0"/>
+              <a:rPr lang="en-GB" dirty="0">
+                <a:latin typeface="Aptos" panose="020B0004020202020204" pitchFamily="34" charset="0"/>
+              </a:rPr>
               <a:t>The red </a:t>
             </a:r>
             <a:r>
               <a:rPr lang="en-GB" dirty="0">
-                <a:latin typeface="Courier" pitchFamily="2" charset="0"/>
+                <a:latin typeface="Courier New" panose="02070309020205020404" pitchFamily="49" charset="0"/>
+                <a:cs typeface="Courier New" panose="02070309020205020404" pitchFamily="49" charset="0"/>
               </a:rPr>
               <a:t>Container</a:t>
             </a:r>
             <a:r>
-              <a:rPr lang="en-GB" dirty="0"/>
+              <a:rPr lang="en-GB" dirty="0">
+                <a:latin typeface="Aptos" panose="020B0004020202020204" pitchFamily="34" charset="0"/>
+              </a:rPr>
               <a:t> wants to be 100 × 100, but it can’t, because the screen forces it to be exactly the same size as the screen.</a:t>
             </a:r>
           </a:p>
           <a:p>
-            <a:endParaRPr lang="en-GB" dirty="0"/>
-          </a:p>
-          <a:p>
-            <a:r>
-              <a:rPr lang="en-GB" dirty="0"/>
+            <a:endParaRPr lang="en-GB" dirty="0">
+              <a:latin typeface="Aptos" panose="020B0004020202020204" pitchFamily="34" charset="0"/>
+            </a:endParaRPr>
+          </a:p>
+          <a:p>
+            <a:r>
+              <a:rPr lang="en-GB" dirty="0">
+                <a:latin typeface="Aptos" panose="020B0004020202020204" pitchFamily="34" charset="0"/>
+              </a:rPr>
               <a:t>The </a:t>
             </a:r>
             <a:r>
               <a:rPr lang="en-GB" dirty="0">
-                <a:latin typeface="Courier" pitchFamily="2" charset="0"/>
+                <a:latin typeface="Courier New" panose="02070309020205020404" pitchFamily="49" charset="0"/>
+                <a:cs typeface="Courier New" panose="02070309020205020404" pitchFamily="49" charset="0"/>
               </a:rPr>
               <a:t>Container</a:t>
             </a:r>
             <a:r>
-              <a:rPr lang="en-GB" dirty="0"/>
+              <a:rPr lang="en-GB" dirty="0">
+                <a:latin typeface="Aptos" panose="020B0004020202020204" pitchFamily="34" charset="0"/>
+              </a:rPr>
               <a:t> fills the screen.</a:t>
             </a:r>
           </a:p>
@@ -15359,63 +15532,89 @@
           </a:p>
           <a:p>
             <a:r>
-              <a:rPr lang="en-GB" dirty="0"/>
+              <a:rPr lang="en-GB" dirty="0">
+                <a:latin typeface="Aptos" panose="020B0004020202020204" pitchFamily="34" charset="0"/>
+              </a:rPr>
               <a:t>The screen forces the </a:t>
             </a:r>
             <a:r>
               <a:rPr lang="en-GB" dirty="0" err="1">
-                <a:latin typeface="Courier" pitchFamily="2" charset="0"/>
+                <a:latin typeface="Courier New" panose="02070309020205020404" pitchFamily="49" charset="0"/>
+                <a:cs typeface="Courier New" panose="02070309020205020404" pitchFamily="49" charset="0"/>
               </a:rPr>
               <a:t>Center</a:t>
             </a:r>
             <a:r>
-              <a:rPr lang="en-GB" dirty="0"/>
-              <a:t> to be exactly the same size as the screen, so the </a:t>
+              <a:rPr lang="en-GB" dirty="0">
+                <a:latin typeface="Aptos" panose="020B0004020202020204" pitchFamily="34" charset="0"/>
+              </a:rPr>
+              <a:t> to be exactly the same size as the screen, so the</a:t>
+            </a:r>
+            <a:r>
+              <a:rPr lang="en-GB" dirty="0">
+                <a:latin typeface="Courier New" panose="02070309020205020404" pitchFamily="49" charset="0"/>
+                <a:cs typeface="Courier New" panose="02070309020205020404" pitchFamily="49" charset="0"/>
+              </a:rPr>
+              <a:t> </a:t>
             </a:r>
             <a:r>
               <a:rPr lang="en-GB" dirty="0" err="1">
-                <a:latin typeface="Courier" pitchFamily="2" charset="0"/>
+                <a:latin typeface="Courier New" panose="02070309020205020404" pitchFamily="49" charset="0"/>
+                <a:cs typeface="Courier New" panose="02070309020205020404" pitchFamily="49" charset="0"/>
               </a:rPr>
               <a:t>Center</a:t>
             </a:r>
             <a:r>
-              <a:rPr lang="en-GB" dirty="0"/>
+              <a:rPr lang="en-GB" dirty="0">
+                <a:latin typeface="Aptos" panose="020B0004020202020204" pitchFamily="34" charset="0"/>
+              </a:rPr>
               <a:t> fills the screen.</a:t>
             </a:r>
           </a:p>
           <a:p>
             <a:r>
-              <a:rPr lang="en-GB" dirty="0"/>
+              <a:rPr lang="en-GB" dirty="0">
+                <a:latin typeface="Aptos" panose="020B0004020202020204" pitchFamily="34" charset="0"/>
+              </a:rPr>
               <a:t>The </a:t>
             </a:r>
             <a:r>
               <a:rPr lang="en-GB" dirty="0" err="1">
-                <a:latin typeface="Courier" pitchFamily="2" charset="0"/>
+                <a:latin typeface="Courier New" panose="02070309020205020404" pitchFamily="49" charset="0"/>
+                <a:cs typeface="Courier New" panose="02070309020205020404" pitchFamily="49" charset="0"/>
               </a:rPr>
               <a:t>Center</a:t>
             </a:r>
             <a:r>
-              <a:rPr lang="en-GB" dirty="0"/>
-              <a:t> tells the</a:t>
-            </a:r>
-            <a:r>
-              <a:rPr lang="en-GB" dirty="0">
-                <a:latin typeface="Courier" pitchFamily="2" charset="0"/>
-              </a:rPr>
-              <a:t> Container</a:t>
-            </a:r>
-            <a:r>
-              <a:rPr lang="en-GB" dirty="0"/>
+              <a:rPr lang="en-GB" dirty="0">
+                <a:latin typeface="Aptos" panose="020B0004020202020204" pitchFamily="34" charset="0"/>
+              </a:rPr>
+              <a:t> tells the </a:t>
+            </a:r>
+            <a:r>
+              <a:rPr lang="en-GB" dirty="0">
+                <a:latin typeface="Courier New" panose="02070309020205020404" pitchFamily="49" charset="0"/>
+                <a:cs typeface="Courier New" panose="02070309020205020404" pitchFamily="49" charset="0"/>
+              </a:rPr>
+              <a:t>Container</a:t>
+            </a:r>
+            <a:r>
+              <a:rPr lang="en-GB" dirty="0">
+                <a:latin typeface="Aptos" panose="020B0004020202020204" pitchFamily="34" charset="0"/>
+              </a:rPr>
               <a:t> that it can be any size it wants, but not bigger than the screen. Now the </a:t>
             </a:r>
             <a:r>
               <a:rPr lang="en-GB" dirty="0">
-                <a:latin typeface="Courier" pitchFamily="2" charset="0"/>
+                <a:latin typeface="Courier New" panose="02070309020205020404" pitchFamily="49" charset="0"/>
+                <a:cs typeface="Courier New" panose="02070309020205020404" pitchFamily="49" charset="0"/>
               </a:rPr>
               <a:t>Container</a:t>
             </a:r>
             <a:r>
-              <a:rPr lang="en-GB" dirty="0"/>
+              <a:rPr lang="en-GB" dirty="0">
+                <a:latin typeface="Aptos" panose="020B0004020202020204" pitchFamily="34" charset="0"/>
+              </a:rPr>
               <a:t> can be 100 × 100.</a:t>
             </a:r>
           </a:p>
@@ -16024,63 +16223,82 @@
           </a:p>
           <a:p>
             <a:r>
-              <a:rPr lang="en-GB" dirty="0"/>
+              <a:rPr lang="en-GB" dirty="0">
+                <a:latin typeface="Aptos" panose="020B0004020202020204" pitchFamily="34" charset="0"/>
+              </a:rPr>
               <a:t>The screen forces the </a:t>
             </a:r>
             <a:r>
               <a:rPr lang="en-GB" dirty="0" err="1">
-                <a:latin typeface="Courier" pitchFamily="2" charset="0"/>
+                <a:latin typeface="Courier New" panose="02070309020205020404" pitchFamily="49" charset="0"/>
+                <a:cs typeface="Courier New" panose="02070309020205020404" pitchFamily="49" charset="0"/>
               </a:rPr>
               <a:t>Center</a:t>
             </a:r>
             <a:r>
-              <a:rPr lang="en-GB" dirty="0"/>
+              <a:rPr lang="en-GB" dirty="0">
+                <a:latin typeface="Aptos" panose="020B0004020202020204" pitchFamily="34" charset="0"/>
+              </a:rPr>
               <a:t> to be exactly the same size as the screen, so the </a:t>
             </a:r>
             <a:r>
               <a:rPr lang="en-GB" dirty="0" err="1">
-                <a:latin typeface="Courier" pitchFamily="2" charset="0"/>
+                <a:latin typeface="Courier New" panose="02070309020205020404" pitchFamily="49" charset="0"/>
+                <a:cs typeface="Courier New" panose="02070309020205020404" pitchFamily="49" charset="0"/>
               </a:rPr>
               <a:t>Center</a:t>
             </a:r>
             <a:r>
-              <a:rPr lang="en-GB" dirty="0"/>
+              <a:rPr lang="en-GB" dirty="0">
+                <a:latin typeface="Aptos" panose="020B0004020202020204" pitchFamily="34" charset="0"/>
+              </a:rPr>
               <a:t> fills the screen.</a:t>
             </a:r>
           </a:p>
           <a:p>
             <a:r>
-              <a:rPr lang="en-GB" dirty="0"/>
+              <a:rPr lang="en-GB" dirty="0">
+                <a:latin typeface="Aptos" panose="020B0004020202020204" pitchFamily="34" charset="0"/>
+              </a:rPr>
               <a:t>The </a:t>
             </a:r>
             <a:r>
               <a:rPr lang="en-GB" dirty="0" err="1">
-                <a:latin typeface="Courier" pitchFamily="2" charset="0"/>
+                <a:latin typeface="Courier New" panose="02070309020205020404" pitchFamily="49" charset="0"/>
+                <a:cs typeface="Courier New" panose="02070309020205020404" pitchFamily="49" charset="0"/>
               </a:rPr>
               <a:t>Center</a:t>
             </a:r>
             <a:r>
-              <a:rPr lang="en-GB" dirty="0"/>
+              <a:rPr lang="en-GB" dirty="0">
+                <a:latin typeface="Aptos" panose="020B0004020202020204" pitchFamily="34" charset="0"/>
+              </a:rPr>
               <a:t> tells the </a:t>
             </a:r>
             <a:r>
               <a:rPr lang="en-GB" dirty="0">
-                <a:latin typeface="Courier" pitchFamily="2" charset="0"/>
+                <a:latin typeface="Courier New" panose="02070309020205020404" pitchFamily="49" charset="0"/>
+                <a:cs typeface="Courier New" panose="02070309020205020404" pitchFamily="49" charset="0"/>
               </a:rPr>
               <a:t>Container</a:t>
             </a:r>
             <a:r>
-              <a:rPr lang="en-GB" dirty="0"/>
+              <a:rPr lang="en-GB" dirty="0">
+                <a:latin typeface="Aptos" panose="020B0004020202020204" pitchFamily="34" charset="0"/>
+              </a:rPr>
               <a:t> that it can be any size it wants, but not bigger than the screen. Since the </a:t>
             </a:r>
             <a:r>
               <a:rPr lang="en-GB" dirty="0">
-                <a:latin typeface="Courier" pitchFamily="2" charset="0"/>
+                <a:latin typeface="Courier New" panose="02070309020205020404" pitchFamily="49" charset="0"/>
+                <a:cs typeface="Courier New" panose="02070309020205020404" pitchFamily="49" charset="0"/>
               </a:rPr>
               <a:t>Container</a:t>
             </a:r>
             <a:r>
-              <a:rPr lang="en-GB" dirty="0"/>
+              <a:rPr lang="en-GB" dirty="0">
+                <a:latin typeface="Aptos" panose="020B0004020202020204" pitchFamily="34" charset="0"/>
+              </a:rPr>
               <a:t> has no child and no fixed size, it decides it wants to be as big as possible, so it fills the whole screen.</a:t>
             </a:r>
           </a:p>
@@ -16443,7 +16661,7 @@
         </p:spPr>
         <p:txBody>
           <a:bodyPr vert="horz" lIns="91440" tIns="45720" rIns="91440" bIns="45720" rtlCol="0">
-            <a:normAutofit fontScale="77500" lnSpcReduction="20000"/>
+            <a:normAutofit fontScale="85000" lnSpcReduction="20000"/>
           </a:bodyPr>
           <a:lstStyle>
             <a:lvl1pPr marL="342900" indent="-342900" algn="l" defTabSz="914400" rtl="0" eaLnBrk="1" latinLnBrk="0" hangingPunct="1">
@@ -16734,133 +16952,175 @@
           </a:p>
           <a:p>
             <a:r>
-              <a:rPr lang="en-GB" dirty="0"/>
+              <a:rPr lang="en-GB" dirty="0">
+                <a:latin typeface="Aptos" panose="020B0004020202020204" pitchFamily="34" charset="0"/>
+              </a:rPr>
               <a:t>The screen forces the </a:t>
             </a:r>
             <a:r>
               <a:rPr lang="en-GB" dirty="0" err="1">
-                <a:latin typeface="Courier" pitchFamily="2" charset="0"/>
+                <a:latin typeface="Courier New" panose="02070309020205020404" pitchFamily="49" charset="0"/>
+                <a:cs typeface="Courier New" panose="02070309020205020404" pitchFamily="49" charset="0"/>
               </a:rPr>
               <a:t>Center</a:t>
             </a:r>
             <a:r>
-              <a:rPr lang="en-GB" dirty="0"/>
+              <a:rPr lang="en-GB" dirty="0">
+                <a:latin typeface="Aptos" panose="020B0004020202020204" pitchFamily="34" charset="0"/>
+              </a:rPr>
               <a:t> to be exactly the same size as the screen, so the </a:t>
             </a:r>
             <a:r>
               <a:rPr lang="en-GB" dirty="0" err="1">
-                <a:latin typeface="Courier" pitchFamily="2" charset="0"/>
+                <a:latin typeface="Courier New" panose="02070309020205020404" pitchFamily="49" charset="0"/>
+                <a:cs typeface="Courier New" panose="02070309020205020404" pitchFamily="49" charset="0"/>
               </a:rPr>
               <a:t>Center</a:t>
             </a:r>
             <a:r>
-              <a:rPr lang="en-GB" dirty="0"/>
+              <a:rPr lang="en-GB" dirty="0">
+                <a:latin typeface="Aptos" panose="020B0004020202020204" pitchFamily="34" charset="0"/>
+              </a:rPr>
               <a:t> fills the screen.</a:t>
             </a:r>
           </a:p>
           <a:p>
             <a:r>
-              <a:rPr lang="en-GB" dirty="0"/>
+              <a:rPr lang="en-GB" dirty="0">
+                <a:latin typeface="Aptos" panose="020B0004020202020204" pitchFamily="34" charset="0"/>
+              </a:rPr>
               <a:t>The </a:t>
             </a:r>
             <a:r>
               <a:rPr lang="en-GB" dirty="0" err="1">
-                <a:latin typeface="Courier" pitchFamily="2" charset="0"/>
+                <a:latin typeface="Courier New" panose="02070309020205020404" pitchFamily="49" charset="0"/>
+                <a:cs typeface="Courier New" panose="02070309020205020404" pitchFamily="49" charset="0"/>
               </a:rPr>
               <a:t>Center</a:t>
             </a:r>
             <a:r>
-              <a:rPr lang="en-GB" dirty="0"/>
+              <a:rPr lang="en-GB" dirty="0">
+                <a:latin typeface="Aptos" panose="020B0004020202020204" pitchFamily="34" charset="0"/>
+              </a:rPr>
               <a:t> tells the red </a:t>
             </a:r>
             <a:r>
               <a:rPr lang="en-GB" dirty="0">
-                <a:latin typeface="Courier" pitchFamily="2" charset="0"/>
+                <a:latin typeface="Courier New" panose="02070309020205020404" pitchFamily="49" charset="0"/>
+                <a:cs typeface="Courier New" panose="02070309020205020404" pitchFamily="49" charset="0"/>
               </a:rPr>
               <a:t>Container</a:t>
             </a:r>
             <a:r>
-              <a:rPr lang="en-GB" dirty="0"/>
+              <a:rPr lang="en-GB" dirty="0">
+                <a:latin typeface="Aptos" panose="020B0004020202020204" pitchFamily="34" charset="0"/>
+              </a:rPr>
               <a:t> that it can be any size it wants, but not bigger than the screen. Since the red </a:t>
             </a:r>
             <a:r>
               <a:rPr lang="en-GB" dirty="0">
-                <a:latin typeface="Courier" pitchFamily="2" charset="0"/>
+                <a:latin typeface="Courier New" panose="02070309020205020404" pitchFamily="49" charset="0"/>
+                <a:cs typeface="Courier New" panose="02070309020205020404" pitchFamily="49" charset="0"/>
               </a:rPr>
               <a:t>Container</a:t>
             </a:r>
             <a:r>
-              <a:rPr lang="en-GB" dirty="0"/>
+              <a:rPr lang="en-GB" dirty="0">
+                <a:latin typeface="Aptos" panose="020B0004020202020204" pitchFamily="34" charset="0"/>
+              </a:rPr>
               <a:t> has no size but has a child, it decides it wants to be the same size as its child.</a:t>
             </a:r>
           </a:p>
           <a:p>
             <a:r>
-              <a:rPr lang="en-GB" dirty="0"/>
+              <a:rPr lang="en-GB" dirty="0">
+                <a:latin typeface="Aptos" panose="020B0004020202020204" pitchFamily="34" charset="0"/>
+              </a:rPr>
               <a:t>The red </a:t>
             </a:r>
             <a:r>
               <a:rPr lang="en-GB" dirty="0">
-                <a:latin typeface="Courier" pitchFamily="2" charset="0"/>
+                <a:latin typeface="Courier New" panose="02070309020205020404" pitchFamily="49" charset="0"/>
+                <a:cs typeface="Courier New" panose="02070309020205020404" pitchFamily="49" charset="0"/>
               </a:rPr>
               <a:t>Container</a:t>
             </a:r>
             <a:r>
-              <a:rPr lang="en-GB" dirty="0"/>
+              <a:rPr lang="en-GB" dirty="0">
+                <a:latin typeface="Aptos" panose="020B0004020202020204" pitchFamily="34" charset="0"/>
+              </a:rPr>
               <a:t> tells its child that it can be any size it wants, but not bigger than the screen.</a:t>
             </a:r>
           </a:p>
           <a:p>
             <a:r>
-              <a:rPr lang="en-GB" dirty="0"/>
+              <a:rPr lang="en-GB" dirty="0">
+                <a:latin typeface="Aptos" panose="020B0004020202020204" pitchFamily="34" charset="0"/>
+              </a:rPr>
               <a:t>The child is a green </a:t>
             </a:r>
             <a:r>
               <a:rPr lang="en-GB" dirty="0">
-                <a:latin typeface="Courier" pitchFamily="2" charset="0"/>
+                <a:latin typeface="Courier New" panose="02070309020205020404" pitchFamily="49" charset="0"/>
+                <a:cs typeface="Courier New" panose="02070309020205020404" pitchFamily="49" charset="0"/>
               </a:rPr>
               <a:t>Container</a:t>
             </a:r>
             <a:r>
-              <a:rPr lang="en-GB" dirty="0"/>
+              <a:rPr lang="en-GB" dirty="0">
+                <a:latin typeface="Aptos" panose="020B0004020202020204" pitchFamily="34" charset="0"/>
+              </a:rPr>
               <a:t> that wants to be 30 × 30. Given that the red </a:t>
             </a:r>
             <a:r>
               <a:rPr lang="en-GB" dirty="0">
-                <a:latin typeface="Courier" pitchFamily="2" charset="0"/>
+                <a:latin typeface="Courier New" panose="02070309020205020404" pitchFamily="49" charset="0"/>
+                <a:cs typeface="Courier New" panose="02070309020205020404" pitchFamily="49" charset="0"/>
               </a:rPr>
               <a:t>Container</a:t>
             </a:r>
             <a:r>
-              <a:rPr lang="en-GB" dirty="0"/>
+              <a:rPr lang="en-GB" dirty="0">
+                <a:latin typeface="Aptos" panose="020B0004020202020204" pitchFamily="34" charset="0"/>
+              </a:rPr>
               <a:t> sizes itself to the size of its child, it is also 30 × 30. The red </a:t>
             </a:r>
             <a:r>
-              <a:rPr lang="en-GB" dirty="0" err="1"/>
+              <a:rPr lang="en-GB" dirty="0" err="1">
+                <a:latin typeface="Aptos" panose="020B0004020202020204" pitchFamily="34" charset="0"/>
+              </a:rPr>
               <a:t>color</a:t>
             </a:r>
             <a:r>
-              <a:rPr lang="en-GB" dirty="0"/>
+              <a:rPr lang="en-GB" dirty="0">
+                <a:latin typeface="Aptos" panose="020B0004020202020204" pitchFamily="34" charset="0"/>
+              </a:rPr>
               <a:t> isn’t visible because the green </a:t>
             </a:r>
             <a:r>
               <a:rPr lang="en-GB" dirty="0">
-                <a:latin typeface="Courier" pitchFamily="2" charset="0"/>
+                <a:latin typeface="Courier New" panose="02070309020205020404" pitchFamily="49" charset="0"/>
+                <a:cs typeface="Courier New" panose="02070309020205020404" pitchFamily="49" charset="0"/>
               </a:rPr>
               <a:t>Container</a:t>
             </a:r>
             <a:r>
-              <a:rPr lang="en-GB" dirty="0"/>
+              <a:rPr lang="en-GB" dirty="0">
+                <a:latin typeface="Aptos" panose="020B0004020202020204" pitchFamily="34" charset="0"/>
+              </a:rPr>
               <a:t> entirely covers the red </a:t>
             </a:r>
             <a:r>
               <a:rPr lang="en-GB" dirty="0">
-                <a:latin typeface="Courier" pitchFamily="2" charset="0"/>
+                <a:latin typeface="Courier New" panose="02070309020205020404" pitchFamily="49" charset="0"/>
+                <a:cs typeface="Courier New" panose="02070309020205020404" pitchFamily="49" charset="0"/>
               </a:rPr>
               <a:t>Container</a:t>
             </a:r>
             <a:r>
-              <a:rPr lang="en-GB" dirty="0"/>
+              <a:rPr lang="en-GB" dirty="0">
+                <a:latin typeface="Aptos" panose="020B0004020202020204" pitchFamily="34" charset="0"/>
+              </a:rPr>
               <a:t>.</a:t>
             </a:r>
           </a:p>
@@ -17472,73 +17732,95 @@
           </a:p>
           <a:p>
             <a:r>
-              <a:rPr lang="en-GB" dirty="0"/>
+              <a:rPr lang="en-GB" dirty="0">
+                <a:latin typeface="Aptos" panose="020B0004020202020204" pitchFamily="34" charset="0"/>
+              </a:rPr>
               <a:t>The screen forces the </a:t>
             </a:r>
             <a:r>
               <a:rPr lang="en-GB" dirty="0" err="1">
-                <a:latin typeface="Courier" pitchFamily="2" charset="0"/>
+                <a:latin typeface="Courier New" panose="02070309020205020404" pitchFamily="49" charset="0"/>
+                <a:cs typeface="Courier New" panose="02070309020205020404" pitchFamily="49" charset="0"/>
               </a:rPr>
               <a:t>UnconstrainedBox</a:t>
             </a:r>
             <a:r>
-              <a:rPr lang="en-GB" dirty="0"/>
+              <a:rPr lang="en-GB" dirty="0">
+                <a:latin typeface="Aptos" panose="020B0004020202020204" pitchFamily="34" charset="0"/>
+              </a:rPr>
               <a:t> to be exactly the same size as the screen, and </a:t>
             </a:r>
             <a:r>
               <a:rPr lang="en-GB" dirty="0" err="1">
-                <a:latin typeface="Courier" pitchFamily="2" charset="0"/>
+                <a:latin typeface="Courier New" panose="02070309020205020404" pitchFamily="49" charset="0"/>
+                <a:cs typeface="Courier New" panose="02070309020205020404" pitchFamily="49" charset="0"/>
               </a:rPr>
               <a:t>UnconstrainedBox</a:t>
             </a:r>
             <a:r>
-              <a:rPr lang="en-GB" dirty="0"/>
+              <a:rPr lang="en-GB" dirty="0">
+                <a:latin typeface="Aptos" panose="020B0004020202020204" pitchFamily="34" charset="0"/>
+              </a:rPr>
               <a:t> lets its child </a:t>
             </a:r>
             <a:r>
               <a:rPr lang="en-GB" dirty="0">
-                <a:latin typeface="Courier" pitchFamily="2" charset="0"/>
+                <a:latin typeface="Courier New" panose="02070309020205020404" pitchFamily="49" charset="0"/>
+                <a:cs typeface="Courier New" panose="02070309020205020404" pitchFamily="49" charset="0"/>
               </a:rPr>
               <a:t>Container</a:t>
             </a:r>
             <a:r>
-              <a:rPr lang="en-GB" dirty="0"/>
+              <a:rPr lang="en-GB" dirty="0">
+                <a:latin typeface="Aptos" panose="020B0004020202020204" pitchFamily="34" charset="0"/>
+              </a:rPr>
               <a:t> be any size it wants.</a:t>
             </a:r>
           </a:p>
           <a:p>
             <a:r>
-              <a:rPr lang="en-GB" dirty="0"/>
+              <a:rPr lang="en-GB" dirty="0">
+                <a:latin typeface="Aptos" panose="020B0004020202020204" pitchFamily="34" charset="0"/>
+              </a:rPr>
               <a:t>Unfortunately, in this case the </a:t>
             </a:r>
             <a:r>
               <a:rPr lang="en-GB" dirty="0">
-                <a:latin typeface="Courier" pitchFamily="2" charset="0"/>
+                <a:latin typeface="Courier New" panose="02070309020205020404" pitchFamily="49" charset="0"/>
+                <a:cs typeface="Courier New" panose="02070309020205020404" pitchFamily="49" charset="0"/>
               </a:rPr>
               <a:t>Container</a:t>
             </a:r>
             <a:r>
-              <a:rPr lang="en-GB" dirty="0"/>
+              <a:rPr lang="en-GB" dirty="0">
+                <a:latin typeface="Aptos" panose="020B0004020202020204" pitchFamily="34" charset="0"/>
+              </a:rPr>
               <a:t> is 4000 pixels wide and is too big to fit in the </a:t>
             </a:r>
             <a:r>
               <a:rPr lang="en-GB" dirty="0" err="1">
-                <a:latin typeface="Courier" pitchFamily="2" charset="0"/>
+                <a:latin typeface="Courier New" panose="02070309020205020404" pitchFamily="49" charset="0"/>
+                <a:cs typeface="Courier New" panose="02070309020205020404" pitchFamily="49" charset="0"/>
               </a:rPr>
               <a:t>UnconstrainedBox</a:t>
             </a:r>
             <a:r>
-              <a:rPr lang="en-GB" dirty="0"/>
+              <a:rPr lang="en-GB" dirty="0">
+                <a:latin typeface="Aptos" panose="020B0004020202020204" pitchFamily="34" charset="0"/>
+              </a:rPr>
               <a:t>, so the </a:t>
             </a:r>
             <a:r>
               <a:rPr lang="en-GB" dirty="0" err="1">
-                <a:latin typeface="Courier" pitchFamily="2" charset="0"/>
+                <a:latin typeface="Courier New" panose="02070309020205020404" pitchFamily="49" charset="0"/>
+                <a:cs typeface="Courier New" panose="02070309020205020404" pitchFamily="49" charset="0"/>
               </a:rPr>
               <a:t>UnconstrainedBox</a:t>
             </a:r>
             <a:r>
-              <a:rPr lang="en-GB" dirty="0"/>
+              <a:rPr lang="en-GB" dirty="0">
+                <a:latin typeface="Aptos" panose="020B0004020202020204" pitchFamily="34" charset="0"/>
+              </a:rPr>
               <a:t> displays the much dreaded “overflow warning”.</a:t>
             </a:r>
           </a:p>
@@ -17933,96 +18215,126 @@
           </a:p>
           <a:p>
             <a:r>
-              <a:rPr lang="en-GB" dirty="0"/>
+              <a:rPr lang="en-GB" dirty="0">
+                <a:latin typeface="Aptos" panose="020B0004020202020204" pitchFamily="34" charset="0"/>
+              </a:rPr>
               <a:t>The screen forces the </a:t>
             </a:r>
             <a:r>
               <a:rPr lang="en-GB" dirty="0" err="1">
-                <a:latin typeface="Courier" pitchFamily="2" charset="0"/>
+                <a:latin typeface="Courier New" panose="02070309020205020404" pitchFamily="49" charset="0"/>
+                <a:cs typeface="Courier New" panose="02070309020205020404" pitchFamily="49" charset="0"/>
               </a:rPr>
               <a:t>FittedBox</a:t>
             </a:r>
             <a:r>
-              <a:rPr lang="en-GB" dirty="0"/>
+              <a:rPr lang="en-GB" dirty="0">
+                <a:latin typeface="Aptos" panose="020B0004020202020204" pitchFamily="34" charset="0"/>
+              </a:rPr>
               <a:t> to be exactly the same size as the screen. The </a:t>
             </a:r>
             <a:r>
               <a:rPr lang="en-GB" dirty="0">
-                <a:latin typeface="Courier" pitchFamily="2" charset="0"/>
+                <a:latin typeface="Courier New" panose="02070309020205020404" pitchFamily="49" charset="0"/>
+                <a:cs typeface="Courier New" panose="02070309020205020404" pitchFamily="49" charset="0"/>
               </a:rPr>
               <a:t>Text</a:t>
             </a:r>
             <a:r>
-              <a:rPr lang="en-GB" dirty="0"/>
+              <a:rPr lang="en-GB" dirty="0">
+                <a:latin typeface="Aptos" panose="020B0004020202020204" pitchFamily="34" charset="0"/>
+              </a:rPr>
               <a:t> has some natural width (also called its intrinsic width) that depends on the amount of text, its font size, and so on.</a:t>
             </a:r>
           </a:p>
           <a:p>
-            <a:endParaRPr lang="en-GB" dirty="0"/>
-          </a:p>
-          <a:p>
-            <a:r>
-              <a:rPr lang="en-GB" dirty="0"/>
+            <a:endParaRPr lang="en-GB" dirty="0">
+              <a:latin typeface="Aptos" panose="020B0004020202020204" pitchFamily="34" charset="0"/>
+            </a:endParaRPr>
+          </a:p>
+          <a:p>
+            <a:r>
+              <a:rPr lang="en-GB" dirty="0">
+                <a:latin typeface="Aptos" panose="020B0004020202020204" pitchFamily="34" charset="0"/>
+              </a:rPr>
               <a:t>The </a:t>
             </a:r>
             <a:r>
               <a:rPr lang="en-GB" dirty="0" err="1">
-                <a:latin typeface="Courier" pitchFamily="2" charset="0"/>
+                <a:latin typeface="Courier New" panose="02070309020205020404" pitchFamily="49" charset="0"/>
+                <a:cs typeface="Courier New" panose="02070309020205020404" pitchFamily="49" charset="0"/>
               </a:rPr>
               <a:t>FittedBox</a:t>
             </a:r>
             <a:r>
-              <a:rPr lang="en-GB" dirty="0"/>
+              <a:rPr lang="en-GB" dirty="0">
+                <a:latin typeface="Aptos" panose="020B0004020202020204" pitchFamily="34" charset="0"/>
+              </a:rPr>
               <a:t> lets the </a:t>
             </a:r>
             <a:r>
               <a:rPr lang="en-GB" dirty="0">
-                <a:latin typeface="Courier" pitchFamily="2" charset="0"/>
+                <a:latin typeface="Courier New" panose="02070309020205020404" pitchFamily="49" charset="0"/>
+                <a:cs typeface="Courier New" panose="02070309020205020404" pitchFamily="49" charset="0"/>
               </a:rPr>
               <a:t>Text</a:t>
             </a:r>
             <a:r>
-              <a:rPr lang="en-GB" dirty="0"/>
+              <a:rPr lang="en-GB" dirty="0">
+                <a:latin typeface="Aptos" panose="020B0004020202020204" pitchFamily="34" charset="0"/>
+              </a:rPr>
               <a:t> be any size it wants, but after the </a:t>
             </a:r>
             <a:r>
               <a:rPr lang="en-GB" dirty="0">
-                <a:latin typeface="Courier" pitchFamily="2" charset="0"/>
+                <a:latin typeface="Courier New" panose="02070309020205020404" pitchFamily="49" charset="0"/>
+                <a:cs typeface="Courier New" panose="02070309020205020404" pitchFamily="49" charset="0"/>
               </a:rPr>
               <a:t>Text</a:t>
             </a:r>
             <a:r>
-              <a:rPr lang="en-GB" dirty="0"/>
+              <a:rPr lang="en-GB" dirty="0">
+                <a:latin typeface="Aptos" panose="020B0004020202020204" pitchFamily="34" charset="0"/>
+              </a:rPr>
               <a:t> tells its size to the </a:t>
             </a:r>
             <a:r>
               <a:rPr lang="en-GB" dirty="0" err="1">
-                <a:latin typeface="Courier" pitchFamily="2" charset="0"/>
+                <a:latin typeface="Courier New" panose="02070309020205020404" pitchFamily="49" charset="0"/>
+                <a:cs typeface="Courier New" panose="02070309020205020404" pitchFamily="49" charset="0"/>
               </a:rPr>
               <a:t>FittedBox</a:t>
             </a:r>
             <a:r>
-              <a:rPr lang="en-GB" dirty="0"/>
+              <a:rPr lang="en-GB" dirty="0">
+                <a:latin typeface="Aptos" panose="020B0004020202020204" pitchFamily="34" charset="0"/>
+              </a:rPr>
               <a:t>, the </a:t>
             </a:r>
             <a:r>
               <a:rPr lang="en-GB" dirty="0" err="1">
-                <a:latin typeface="Courier" pitchFamily="2" charset="0"/>
+                <a:latin typeface="Courier New" panose="02070309020205020404" pitchFamily="49" charset="0"/>
+                <a:cs typeface="Courier New" panose="02070309020205020404" pitchFamily="49" charset="0"/>
               </a:rPr>
               <a:t>FittedBox</a:t>
             </a:r>
             <a:r>
-              <a:rPr lang="en-GB" dirty="0"/>
+              <a:rPr lang="en-GB" dirty="0">
+                <a:latin typeface="Aptos" panose="020B0004020202020204" pitchFamily="34" charset="0"/>
+              </a:rPr>
               <a:t> scales the </a:t>
             </a:r>
             <a:r>
               <a:rPr lang="en-GB" dirty="0">
-                <a:latin typeface="Courier" pitchFamily="2" charset="0"/>
+                <a:latin typeface="Courier New" panose="02070309020205020404" pitchFamily="49" charset="0"/>
+                <a:cs typeface="Courier New" panose="02070309020205020404" pitchFamily="49" charset="0"/>
               </a:rPr>
               <a:t>Text</a:t>
             </a:r>
             <a:r>
-              <a:rPr lang="en-GB" dirty="0"/>
+              <a:rPr lang="en-GB" dirty="0">
+                <a:latin typeface="Aptos" panose="020B0004020202020204" pitchFamily="34" charset="0"/>
+              </a:rPr>
               <a:t> until it fills all of the available width.</a:t>
             </a:r>
           </a:p>
@@ -18663,103 +18975,134 @@
           </a:p>
           <a:p>
             <a:r>
-              <a:rPr lang="en-GB" dirty="0"/>
+              <a:rPr lang="en-GB" dirty="0">
+                <a:latin typeface="Aptos" panose="020B0004020202020204" pitchFamily="34" charset="0"/>
+              </a:rPr>
               <a:t>But what happens if you put the </a:t>
             </a:r>
             <a:r>
               <a:rPr lang="en-GB" dirty="0" err="1">
-                <a:latin typeface="Courier" pitchFamily="2" charset="0"/>
+                <a:latin typeface="Courier New" panose="02070309020205020404" pitchFamily="49" charset="0"/>
+                <a:cs typeface="Courier New" panose="02070309020205020404" pitchFamily="49" charset="0"/>
               </a:rPr>
               <a:t>FittedBox</a:t>
             </a:r>
             <a:r>
-              <a:rPr lang="en-GB" dirty="0"/>
+              <a:rPr lang="en-GB" dirty="0">
+                <a:latin typeface="Aptos" panose="020B0004020202020204" pitchFamily="34" charset="0"/>
+              </a:rPr>
               <a:t> inside of a </a:t>
             </a:r>
             <a:r>
               <a:rPr lang="en-GB" dirty="0" err="1">
-                <a:latin typeface="Courier" pitchFamily="2" charset="0"/>
+                <a:latin typeface="Courier New" panose="02070309020205020404" pitchFamily="49" charset="0"/>
+                <a:cs typeface="Courier New" panose="02070309020205020404" pitchFamily="49" charset="0"/>
               </a:rPr>
               <a:t>Center</a:t>
             </a:r>
             <a:r>
-              <a:rPr lang="en-GB" dirty="0"/>
+              <a:rPr lang="en-GB" dirty="0">
+                <a:latin typeface="Aptos" panose="020B0004020202020204" pitchFamily="34" charset="0"/>
+              </a:rPr>
               <a:t> widget? The </a:t>
             </a:r>
             <a:r>
               <a:rPr lang="en-GB" dirty="0" err="1">
-                <a:latin typeface="Courier" pitchFamily="2" charset="0"/>
+                <a:latin typeface="Courier New" panose="02070309020205020404" pitchFamily="49" charset="0"/>
+                <a:cs typeface="Courier New" panose="02070309020205020404" pitchFamily="49" charset="0"/>
               </a:rPr>
               <a:t>Center</a:t>
             </a:r>
             <a:r>
-              <a:rPr lang="en-GB" dirty="0"/>
+              <a:rPr lang="en-GB" dirty="0">
+                <a:latin typeface="Aptos" panose="020B0004020202020204" pitchFamily="34" charset="0"/>
+              </a:rPr>
               <a:t> lets the </a:t>
             </a:r>
             <a:r>
               <a:rPr lang="en-GB" dirty="0" err="1">
-                <a:latin typeface="Courier" pitchFamily="2" charset="0"/>
+                <a:latin typeface="Courier New" panose="02070309020205020404" pitchFamily="49" charset="0"/>
+                <a:cs typeface="Courier New" panose="02070309020205020404" pitchFamily="49" charset="0"/>
               </a:rPr>
               <a:t>FittedBox</a:t>
             </a:r>
             <a:r>
-              <a:rPr lang="en-GB" dirty="0"/>
+              <a:rPr lang="en-GB" dirty="0">
+                <a:latin typeface="Aptos" panose="020B0004020202020204" pitchFamily="34" charset="0"/>
+              </a:rPr>
               <a:t> be any size it wants, up to the screen size.</a:t>
             </a:r>
           </a:p>
           <a:p>
             <a:r>
-              <a:rPr lang="en-GB" dirty="0"/>
+              <a:rPr lang="en-GB" dirty="0">
+                <a:latin typeface="Aptos" panose="020B0004020202020204" pitchFamily="34" charset="0"/>
+              </a:rPr>
               <a:t>The </a:t>
             </a:r>
             <a:r>
               <a:rPr lang="en-GB" dirty="0" err="1">
-                <a:latin typeface="Courier" pitchFamily="2" charset="0"/>
+                <a:latin typeface="Courier New" panose="02070309020205020404" pitchFamily="49" charset="0"/>
+                <a:cs typeface="Courier New" panose="02070309020205020404" pitchFamily="49" charset="0"/>
               </a:rPr>
               <a:t>FittedBox</a:t>
             </a:r>
             <a:r>
-              <a:rPr lang="en-GB" dirty="0"/>
+              <a:rPr lang="en-GB" dirty="0">
+                <a:latin typeface="Aptos" panose="020B0004020202020204" pitchFamily="34" charset="0"/>
+              </a:rPr>
               <a:t> then sizes itself to the </a:t>
             </a:r>
             <a:r>
               <a:rPr lang="en-GB" dirty="0">
-                <a:latin typeface="Courier" pitchFamily="2" charset="0"/>
+                <a:latin typeface="Courier New" panose="02070309020205020404" pitchFamily="49" charset="0"/>
+                <a:cs typeface="Courier New" panose="02070309020205020404" pitchFamily="49" charset="0"/>
               </a:rPr>
               <a:t>Text</a:t>
             </a:r>
             <a:r>
-              <a:rPr lang="en-GB" dirty="0"/>
+              <a:rPr lang="en-GB" dirty="0">
+                <a:latin typeface="Aptos" panose="020B0004020202020204" pitchFamily="34" charset="0"/>
+              </a:rPr>
               <a:t>, and lets the </a:t>
             </a:r>
             <a:r>
               <a:rPr lang="en-GB" dirty="0">
-                <a:latin typeface="Courier" pitchFamily="2" charset="0"/>
+                <a:latin typeface="Courier New" panose="02070309020205020404" pitchFamily="49" charset="0"/>
+                <a:cs typeface="Courier New" panose="02070309020205020404" pitchFamily="49" charset="0"/>
               </a:rPr>
               <a:t>Text</a:t>
             </a:r>
             <a:r>
-              <a:rPr lang="en-GB" dirty="0"/>
+              <a:rPr lang="en-GB" dirty="0">
+                <a:latin typeface="Aptos" panose="020B0004020202020204" pitchFamily="34" charset="0"/>
+              </a:rPr>
               <a:t> be any size it wants. Since both </a:t>
             </a:r>
             <a:r>
               <a:rPr lang="en-GB" dirty="0" err="1">
-                <a:latin typeface="Courier" pitchFamily="2" charset="0"/>
+                <a:latin typeface="Courier New" panose="02070309020205020404" pitchFamily="49" charset="0"/>
+                <a:cs typeface="Courier New" panose="02070309020205020404" pitchFamily="49" charset="0"/>
               </a:rPr>
               <a:t>FittedBox</a:t>
             </a:r>
             <a:r>
-              <a:rPr lang="en-GB" dirty="0"/>
+              <a:rPr lang="en-GB" dirty="0">
+                <a:latin typeface="Aptos" panose="020B0004020202020204" pitchFamily="34" charset="0"/>
+              </a:rPr>
               <a:t> and the </a:t>
             </a:r>
             <a:r>
               <a:rPr lang="en-GB" dirty="0">
-                <a:latin typeface="Courier" pitchFamily="2" charset="0"/>
+                <a:latin typeface="Courier New" panose="02070309020205020404" pitchFamily="49" charset="0"/>
+                <a:cs typeface="Courier New" panose="02070309020205020404" pitchFamily="49" charset="0"/>
               </a:rPr>
               <a:t>Text</a:t>
             </a:r>
             <a:r>
-              <a:rPr lang="en-GB" dirty="0"/>
+              <a:rPr lang="en-GB" dirty="0">
+                <a:latin typeface="Aptos" panose="020B0004020202020204" pitchFamily="34" charset="0"/>
+              </a:rPr>
               <a:t> have the same size, no scaling happens.</a:t>
             </a:r>
           </a:p>
@@ -19013,6 +19356,7 @@
             </a:pPr>
             <a:r>
               <a:rPr lang="en-IT" sz="1600" dirty="0">
+                <a:latin typeface="Aptos" panose="020B0004020202020204" pitchFamily="34" charset="0"/>
                 <a:ea typeface="Palatino" pitchFamily="2" charset="77"/>
               </a:rPr>
               <a:t>Full example in lab_05-understanding_ui/layout_basics/</a:t>
@@ -29227,6 +29571,7 @@
             </a:pPr>
             <a:r>
               <a:rPr lang="en-IT" sz="1600" dirty="0">
+                <a:latin typeface="Aptos" panose="020B0004020202020204" pitchFamily="34" charset="0"/>
                 <a:ea typeface="Palatino" pitchFamily="2" charset="77"/>
               </a:rPr>
               <a:t>Full example in lab_05-understanding_ui/scaffolding/</a:t>
@@ -30723,6 +31068,7 @@
             </a:pPr>
             <a:r>
               <a:rPr lang="en-IT" sz="1600" dirty="0">
+                <a:latin typeface="Aptos" panose="020B0004020202020204" pitchFamily="34" charset="0"/>
                 <a:ea typeface="Palatino" pitchFamily="2" charset="77"/>
               </a:rPr>
               <a:t>Full example in lab_05-understanding_ui/scaffolding/</a:t>
@@ -32382,7 +32728,9 @@
           </a:lstStyle>
           <a:p>
             <a:r>
-              <a:rPr lang="en-IT" dirty="0"/>
+              <a:rPr lang="en-IT" dirty="0">
+                <a:latin typeface="Aptos" panose="020B0004020202020204" pitchFamily="34" charset="0"/>
+              </a:rPr>
               <a:t>Of course, there are many others…</a:t>
             </a:r>
           </a:p>
@@ -34091,7 +34439,9 @@
           </a:lstStyle>
           <a:p>
             <a:r>
-              <a:rPr lang="en-IT" dirty="0"/>
+              <a:rPr lang="en-IT" dirty="0">
+                <a:latin typeface="Aptos" panose="020B0004020202020204" pitchFamily="34" charset="0"/>
+              </a:rPr>
               <a:t>Of course, there are many others…</a:t>
             </a:r>
           </a:p>
@@ -34609,7 +34959,9 @@
           </a:lstStyle>
           <a:p>
             <a:r>
-              <a:rPr lang="en-IT" dirty="0"/>
+              <a:rPr lang="en-IT" dirty="0">
+                <a:latin typeface="Aptos" panose="020B0004020202020204" pitchFamily="34" charset="0"/>
+              </a:rPr>
               <a:t>Of course, there are many others…</a:t>
             </a:r>
           </a:p>
@@ -34970,7 +35322,9 @@
               <a:buNone/>
             </a:pPr>
             <a:r>
-              <a:rPr lang="en-IT" b="1" dirty="0"/>
+              <a:rPr lang="en-IT" b="1" dirty="0">
+                <a:latin typeface="Aptos" panose="020B0004020202020204" pitchFamily="34" charset="0"/>
+              </a:rPr>
               <a:t>Extensively discussed in the next lesson</a:t>
             </a:r>
           </a:p>
@@ -35315,27 +35669,37 @@
           </a:lstStyle>
           <a:p>
             <a:r>
-              <a:rPr lang="en-IT" dirty="0"/>
+              <a:rPr lang="en-IT" dirty="0">
+                <a:latin typeface="Aptos" panose="020B0004020202020204" pitchFamily="34" charset="0"/>
+              </a:rPr>
               <a:t>Many approaches can be followed</a:t>
             </a:r>
           </a:p>
           <a:p>
             <a:r>
-              <a:rPr lang="en-IT" b="1" dirty="0"/>
+              <a:rPr lang="en-IT" b="1" dirty="0">
+                <a:latin typeface="Aptos" panose="020B0004020202020204" pitchFamily="34" charset="0"/>
+              </a:rPr>
               <a:t>Material</a:t>
             </a:r>
             <a:r>
-              <a:rPr lang="en-IT" dirty="0"/>
+              <a:rPr lang="en-IT" dirty="0">
+                <a:latin typeface="Aptos" panose="020B0004020202020204" pitchFamily="34" charset="0"/>
+              </a:rPr>
               <a:t> is an adaptable system of guidelines, components, and tools to support </a:t>
             </a:r>
             <a:r>
-              <a:rPr lang="en-IT" b="1" dirty="0"/>
+              <a:rPr lang="en-IT" b="1" dirty="0">
+                <a:latin typeface="Aptos" panose="020B0004020202020204" pitchFamily="34" charset="0"/>
+              </a:rPr>
               <a:t>best practices of UI design</a:t>
             </a:r>
           </a:p>
           <a:p>
             <a:r>
-              <a:rPr lang="en-IT" dirty="0"/>
+              <a:rPr lang="en-IT" dirty="0">
+                <a:latin typeface="Aptos" panose="020B0004020202020204" pitchFamily="34" charset="0"/>
+              </a:rPr>
               <a:t>Flutter includes many widgets from Material</a:t>
             </a:r>
           </a:p>
@@ -35673,7 +36037,9 @@
           </a:lstStyle>
           <a:p>
             <a:r>
-              <a:rPr lang="en-IT" dirty="0"/>
+              <a:rPr lang="en-IT" dirty="0">
+                <a:latin typeface="Aptos" panose="020B0004020202020204" pitchFamily="34" charset="0"/>
+              </a:rPr>
               <a:t>Of course, there are many others…</a:t>
             </a:r>
           </a:p>

</xml_diff>